<commit_message>
Inhaltsangabe pptx + mathe
</commit_message>
<xml_diff>
--- a/Labor/Signitzer/nas.pptx
+++ b/Labor/Signitzer/nas.pptx
@@ -5,22 +5,24 @@
     <p:sldMasterId id="2147483744" r:id="rId1"/>
   </p:sldMasterIdLst>
   <p:notesMasterIdLst>
-    <p:notesMasterId r:id="rId15"/>
+    <p:notesMasterId r:id="rId17"/>
   </p:notesMasterIdLst>
   <p:sldIdLst>
     <p:sldId id="256" r:id="rId2"/>
-    <p:sldId id="268" r:id="rId3"/>
-    <p:sldId id="257" r:id="rId4"/>
-    <p:sldId id="258" r:id="rId5"/>
-    <p:sldId id="259" r:id="rId6"/>
-    <p:sldId id="260" r:id="rId7"/>
-    <p:sldId id="261" r:id="rId8"/>
-    <p:sldId id="262" r:id="rId9"/>
-    <p:sldId id="263" r:id="rId10"/>
-    <p:sldId id="264" r:id="rId11"/>
-    <p:sldId id="265" r:id="rId12"/>
-    <p:sldId id="266" r:id="rId13"/>
-    <p:sldId id="267" r:id="rId14"/>
+    <p:sldId id="314" r:id="rId3"/>
+    <p:sldId id="268" r:id="rId4"/>
+    <p:sldId id="257" r:id="rId5"/>
+    <p:sldId id="258" r:id="rId6"/>
+    <p:sldId id="259" r:id="rId7"/>
+    <p:sldId id="260" r:id="rId8"/>
+    <p:sldId id="315" r:id="rId9"/>
+    <p:sldId id="261" r:id="rId10"/>
+    <p:sldId id="262" r:id="rId11"/>
+    <p:sldId id="263" r:id="rId12"/>
+    <p:sldId id="264" r:id="rId13"/>
+    <p:sldId id="265" r:id="rId14"/>
+    <p:sldId id="266" r:id="rId15"/>
+    <p:sldId id="267" r:id="rId16"/>
   </p:sldIdLst>
   <p:sldSz cx="12192000" cy="6858000"/>
   <p:notesSz cx="6858000" cy="9144000"/>
@@ -10176,10 +10178,10 @@
       </p:grpSpPr>
       <p:sp>
         <p:nvSpPr>
-          <p:cNvPr id="2" name="Title 1">
-            <a:extLst>
-              <a:ext uri="{FF2B5EF4-FFF2-40B4-BE49-F238E27FC236}">
-                <a16:creationId xmlns:a16="http://schemas.microsoft.com/office/drawing/2014/main" id="{198C43F5-C69B-793B-9C6A-83C1F0823EEF}"/>
+          <p:cNvPr id="5" name="Title 4">
+            <a:extLst>
+              <a:ext uri="{FF2B5EF4-FFF2-40B4-BE49-F238E27FC236}">
+                <a16:creationId xmlns:a16="http://schemas.microsoft.com/office/drawing/2014/main" id="{AB223F16-287D-411A-C8CD-B223D8AA4747}"/>
               </a:ext>
             </a:extLst>
           </p:cNvPr>
@@ -10196,27 +10198,34 @@
           <a:lstStyle/>
           <a:p>
             <a:r>
+              <a:rPr lang="de-AT" noProof="0" dirty="0"/>
+              <a:t>Warum </a:t>
+            </a:r>
+            <a:r>
+              <a:rPr lang="de-AT" noProof="0" dirty="0" err="1"/>
+              <a:t>Proxmox</a:t>
+            </a:r>
+            <a:r>
+              <a:rPr lang="de-AT" noProof="0" dirty="0"/>
+              <a:t> mit </a:t>
+            </a:r>
+            <a:r>
               <a:rPr lang="de-AT" noProof="0" dirty="0" err="1"/>
               <a:t>Truenas</a:t>
             </a:r>
             <a:r>
               <a:rPr lang="de-AT" noProof="0" dirty="0"/>
-              <a:t> </a:t>
-            </a:r>
-            <a:r>
-              <a:rPr lang="de-AT" noProof="0" dirty="0" err="1"/>
-              <a:t>COnfig</a:t>
-            </a:r>
-            <a:endParaRPr lang="de-AT" noProof="0" dirty="0"/>
-          </a:p>
-        </p:txBody>
-      </p:sp>
-      <p:sp>
-        <p:nvSpPr>
-          <p:cNvPr id="3" name="Content Placeholder 2">
-            <a:extLst>
-              <a:ext uri="{FF2B5EF4-FFF2-40B4-BE49-F238E27FC236}">
-                <a16:creationId xmlns:a16="http://schemas.microsoft.com/office/drawing/2014/main" id="{13A11DA4-EB64-9E64-4B8F-C7AD9A563651}"/>
+              <a:t>?</a:t>
+            </a:r>
+          </a:p>
+        </p:txBody>
+      </p:sp>
+      <p:sp>
+        <p:nvSpPr>
+          <p:cNvPr id="6" name="Content Placeholder 5">
+            <a:extLst>
+              <a:ext uri="{FF2B5EF4-FFF2-40B4-BE49-F238E27FC236}">
+                <a16:creationId xmlns:a16="http://schemas.microsoft.com/office/drawing/2014/main" id="{4055BCF1-EAD7-301E-60E9-215796AAF546}"/>
               </a:ext>
             </a:extLst>
           </p:cNvPr>
@@ -10233,66 +10242,44 @@
           <a:lstStyle/>
           <a:p>
             <a:r>
+              <a:rPr lang="de-AT" noProof="0" dirty="0" err="1"/>
+              <a:t>Proxmox</a:t>
+            </a:r>
+            <a:r>
               <a:rPr lang="de-AT" noProof="0" dirty="0"/>
-              <a:t>ZFS Pool (2x320GB HDD)</a:t>
+              <a:t> wegen Kenntnissen vom eigenen Serverbau</a:t>
             </a:r>
           </a:p>
           <a:p>
             <a:r>
               <a:rPr lang="de-AT" noProof="0" dirty="0"/>
-              <a:t>Eigene Datasets jeweils für Fronthaler, Glatz, </a:t>
-            </a:r>
+              <a:t>Zusätzliche Services mit Helper Scripts einfach installierbar</a:t>
+            </a:r>
+          </a:p>
+          <a:p>
+            <a:r>
+              <a:rPr lang="de-AT" noProof="0" dirty="0"/>
+              <a:t>Services sind Leicht trennbar</a:t>
+            </a:r>
+          </a:p>
+          <a:p>
             <a:r>
               <a:rPr lang="de-AT" noProof="0" dirty="0" err="1"/>
-              <a:t>Signitzer</a:t>
-            </a:r>
-            <a:endParaRPr lang="de-AT" noProof="0" dirty="0"/>
-          </a:p>
-          <a:p>
-            <a:r>
-              <a:rPr lang="de-AT" noProof="0" dirty="0" err="1"/>
-              <a:t>Shared</a:t>
+              <a:t>TrueNAS</a:t>
             </a:r>
             <a:r>
               <a:rPr lang="de-AT" noProof="0" dirty="0"/>
-              <a:t> Dataset für alle</a:t>
-            </a:r>
-          </a:p>
-          <a:p>
-            <a:r>
-              <a:rPr lang="de-AT" noProof="0" dirty="0"/>
-              <a:t>SMB und NFS Share (/</a:t>
-            </a:r>
-            <a:r>
-              <a:rPr lang="de-AT" noProof="0" dirty="0" err="1"/>
-              <a:t>mnt</a:t>
-            </a:r>
-            <a:r>
-              <a:rPr lang="de-AT" noProof="0" dirty="0"/>
-              <a:t>/DATA/…) eingerichtet</a:t>
-            </a:r>
-          </a:p>
-          <a:p>
-            <a:pPr lvl="1"/>
-            <a:endParaRPr lang="de-AT" noProof="0" dirty="0"/>
-          </a:p>
-          <a:p>
-            <a:endParaRPr lang="de-AT" noProof="0" dirty="0"/>
-          </a:p>
-          <a:p>
-            <a:endParaRPr lang="de-AT" noProof="0" dirty="0"/>
-          </a:p>
-          <a:p>
-            <a:endParaRPr lang="de-AT" noProof="0" dirty="0"/>
-          </a:p>
-        </p:txBody>
-      </p:sp>
-      <p:sp>
-        <p:nvSpPr>
-          <p:cNvPr id="4" name="Slide Number Placeholder 3">
-            <a:extLst>
-              <a:ext uri="{FF2B5EF4-FFF2-40B4-BE49-F238E27FC236}">
-                <a16:creationId xmlns:a16="http://schemas.microsoft.com/office/drawing/2014/main" id="{65D87626-8F8F-0CF7-FEB9-783E0646F45E}"/>
+              <a:t> hat eine schöne Oberfläche und ist einfach konfigurierbar</a:t>
+            </a:r>
+          </a:p>
+        </p:txBody>
+      </p:sp>
+      <p:sp>
+        <p:nvSpPr>
+          <p:cNvPr id="7" name="Slide Number Placeholder 6">
+            <a:extLst>
+              <a:ext uri="{FF2B5EF4-FFF2-40B4-BE49-F238E27FC236}">
+                <a16:creationId xmlns:a16="http://schemas.microsoft.com/office/drawing/2014/main" id="{AD11AFFF-5229-F451-61F1-887D21EF3322}"/>
               </a:ext>
             </a:extLst>
           </p:cNvPr>
@@ -10318,10 +10305,10 @@
       </p:sp>
       <p:pic>
         <p:nvPicPr>
-          <p:cNvPr id="5" name="Picture 4" descr="Samba Server Icon &amp; Logo | Dashboard Icons &amp; Logos">
-            <a:extLst>
-              <a:ext uri="{FF2B5EF4-FFF2-40B4-BE49-F238E27FC236}">
-                <a16:creationId xmlns:a16="http://schemas.microsoft.com/office/drawing/2014/main" id="{FA8B58A0-E126-4A12-B4B9-79576B801716}"/>
+          <p:cNvPr id="2" name="Picture 1" descr="Proxmox Icon &amp; Logo (selfh.st) | Dashboard Icons &amp; Logos">
+            <a:extLst>
+              <a:ext uri="{FF2B5EF4-FFF2-40B4-BE49-F238E27FC236}">
+                <a16:creationId xmlns:a16="http://schemas.microsoft.com/office/drawing/2014/main" id="{1D2B0203-C2B3-C9E1-6EAE-BDE02BCB0375}"/>
               </a:ext>
             </a:extLst>
           </p:cNvPr>
@@ -10338,8 +10325,38 @@
         </p:blipFill>
         <p:spPr>
           <a:xfrm>
-            <a:off x="405226" y="4437116"/>
-            <a:ext cx="1772490" cy="1614795"/>
+            <a:off x="617773" y="4451684"/>
+            <a:ext cx="1577474" cy="1577474"/>
+          </a:xfrm>
+          <a:prstGeom prst="rect">
+            <a:avLst/>
+          </a:prstGeom>
+        </p:spPr>
+      </p:pic>
+      <p:pic>
+        <p:nvPicPr>
+          <p:cNvPr id="3" name="Picture 2" descr="Truenas Icon &amp; Logo | Dashboard Icons &amp; Logos">
+            <a:extLst>
+              <a:ext uri="{FF2B5EF4-FFF2-40B4-BE49-F238E27FC236}">
+                <a16:creationId xmlns:a16="http://schemas.microsoft.com/office/drawing/2014/main" id="{0BA6FC60-B779-AE27-CD8A-DB044F0DC658}"/>
+              </a:ext>
+            </a:extLst>
+          </p:cNvPr>
+          <p:cNvPicPr>
+            <a:picLocks noChangeAspect="1"/>
+          </p:cNvPicPr>
+          <p:nvPr/>
+        </p:nvPicPr>
+        <p:blipFill>
+          <a:blip r:embed="rId3"/>
+          <a:stretch>
+            <a:fillRect/>
+          </a:stretch>
+        </p:blipFill>
+        <p:spPr>
+          <a:xfrm>
+            <a:off x="3007894" y="4451684"/>
+            <a:ext cx="2192421" cy="1732283"/>
           </a:xfrm>
           <a:prstGeom prst="rect">
             <a:avLst/>
@@ -10349,7 +10366,7 @@
     </p:spTree>
     <p:extLst>
       <p:ext uri="{BB962C8B-B14F-4D97-AF65-F5344CB8AC3E}">
-        <p14:creationId xmlns:p14="http://schemas.microsoft.com/office/powerpoint/2010/main" val="1726425326"/>
+        <p14:creationId xmlns:p14="http://schemas.microsoft.com/office/powerpoint/2010/main" val="4224059100"/>
       </p:ext>
     </p:extLst>
   </p:cSld>
@@ -10381,7 +10398,7 @@
           <p:cNvPr id="2" name="Title 1">
             <a:extLst>
               <a:ext uri="{FF2B5EF4-FFF2-40B4-BE49-F238E27FC236}">
-                <a16:creationId xmlns:a16="http://schemas.microsoft.com/office/drawing/2014/main" id="{E265C372-F4F4-7A48-C4F2-7B5F5366A619}"/>
+                <a16:creationId xmlns:a16="http://schemas.microsoft.com/office/drawing/2014/main" id="{E8FB61DF-3FC1-44F2-6593-9C30C42976AD}"/>
               </a:ext>
             </a:extLst>
           </p:cNvPr>
@@ -10399,8 +10416,13 @@
           <a:p>
             <a:r>
               <a:rPr lang="de-AT" noProof="0" dirty="0"/>
-              <a:t>Services</a:t>
-            </a:r>
+              <a:t>Festplatten </a:t>
+            </a:r>
+            <a:r>
+              <a:rPr lang="de-AT" noProof="0" dirty="0" err="1"/>
+              <a:t>setup</a:t>
+            </a:r>
+            <a:endParaRPr lang="de-AT" noProof="0" dirty="0"/>
           </a:p>
         </p:txBody>
       </p:sp>
@@ -10409,7 +10431,7 @@
           <p:cNvPr id="3" name="Content Placeholder 2">
             <a:extLst>
               <a:ext uri="{FF2B5EF4-FFF2-40B4-BE49-F238E27FC236}">
-                <a16:creationId xmlns:a16="http://schemas.microsoft.com/office/drawing/2014/main" id="{9FB4E924-E1ED-52CE-B3E9-DA9A879DC1C3}"/>
+                <a16:creationId xmlns:a16="http://schemas.microsoft.com/office/drawing/2014/main" id="{DDBC0929-008A-B2F3-DBCF-31456F2A6092}"/>
               </a:ext>
             </a:extLst>
           </p:cNvPr>
@@ -10426,88 +10448,34 @@
           <a:lstStyle/>
           <a:p>
             <a:r>
+              <a:rPr lang="de-AT" noProof="0" dirty="0"/>
+              <a:t>Alle Festplatten zuerst </a:t>
+            </a:r>
+            <a:r>
               <a:rPr lang="de-AT" noProof="0" dirty="0" err="1"/>
-              <a:t>Jellyfin</a:t>
+              <a:t>gewiped</a:t>
+            </a:r>
+            <a:endParaRPr lang="de-AT" noProof="0" dirty="0"/>
+          </a:p>
+          <a:p>
+            <a:r>
+              <a:rPr lang="de-AT" noProof="0" dirty="0" err="1"/>
+              <a:t>Proxmox</a:t>
             </a:r>
             <a:r>
               <a:rPr lang="de-AT" noProof="0" dirty="0"/>
-              <a:t> </a:t>
-            </a:r>
-          </a:p>
-          <a:p>
-            <a:pPr lvl="1"/>
-            <a:r>
-              <a:rPr lang="de-AT" noProof="0" dirty="0" err="1"/>
-              <a:t>Unpriviledged</a:t>
-            </a:r>
+              <a:t> mit anderen Services auf einer 250GB HDD</a:t>
+            </a:r>
+          </a:p>
+          <a:p>
             <a:r>
               <a:rPr lang="de-AT" noProof="0" dirty="0"/>
-              <a:t> LXC </a:t>
-            </a:r>
-            <a:r>
-              <a:rPr lang="de-AT" noProof="0" dirty="0" err="1"/>
-              <a:t>container</a:t>
-            </a:r>
+              <a:t>Raid 1 mit 2x 320GB HDD</a:t>
+            </a:r>
+          </a:p>
+          <a:p>
             <a:endParaRPr lang="de-AT" noProof="0" dirty="0"/>
           </a:p>
-          <a:p>
-            <a:pPr lvl="1"/>
-            <a:r>
-              <a:rPr lang="de-AT" noProof="0" dirty="0"/>
-              <a:t>Um auf die Festplatten zugreifen zu können braucht es extra Zugriffsrechte</a:t>
-            </a:r>
-          </a:p>
-          <a:p>
-            <a:pPr marL="457200" lvl="1" indent="0">
-              <a:buNone/>
-            </a:pPr>
-            <a:endParaRPr lang="de-AT" noProof="0" dirty="0"/>
-          </a:p>
-          <a:p>
-            <a:r>
-              <a:rPr lang="de-AT" noProof="0" dirty="0" err="1"/>
-              <a:t>qBittorrent</a:t>
-            </a:r>
-            <a:endParaRPr lang="de-AT" noProof="0" dirty="0"/>
-          </a:p>
-          <a:p>
-            <a:pPr lvl="1"/>
-            <a:r>
-              <a:rPr lang="de-AT" noProof="0" dirty="0" err="1"/>
-              <a:t>Unpriviledged</a:t>
-            </a:r>
-            <a:r>
-              <a:rPr lang="de-AT" noProof="0" dirty="0"/>
-              <a:t> LXC </a:t>
-            </a:r>
-            <a:r>
-              <a:rPr lang="de-AT" noProof="0" dirty="0" err="1"/>
-              <a:t>container</a:t>
-            </a:r>
-            <a:endParaRPr lang="de-AT" noProof="0" dirty="0"/>
-          </a:p>
-          <a:p>
-            <a:pPr lvl="1"/>
-            <a:r>
-              <a:rPr lang="de-AT" noProof="0" dirty="0"/>
-              <a:t>Torrenten im Schulnetz geblockt</a:t>
-            </a:r>
-          </a:p>
-          <a:p>
-            <a:pPr marL="457200" lvl="1" indent="0">
-              <a:buNone/>
-            </a:pPr>
-            <a:endParaRPr lang="de-AT" noProof="0" dirty="0"/>
-          </a:p>
-          <a:p>
-            <a:r>
-              <a:rPr lang="de-AT" noProof="0" dirty="0"/>
-              <a:t>Installiert mit Helper Scripts</a:t>
-            </a:r>
-          </a:p>
-          <a:p>
-            <a:endParaRPr lang="de-AT" noProof="0" dirty="0"/>
-          </a:p>
         </p:txBody>
       </p:sp>
       <p:sp>
@@ -10515,7 +10483,7 @@
           <p:cNvPr id="4" name="Slide Number Placeholder 3">
             <a:extLst>
               <a:ext uri="{FF2B5EF4-FFF2-40B4-BE49-F238E27FC236}">
-                <a16:creationId xmlns:a16="http://schemas.microsoft.com/office/drawing/2014/main" id="{A299164C-61EF-39D0-FC1D-32FC00147B09}"/>
+                <a16:creationId xmlns:a16="http://schemas.microsoft.com/office/drawing/2014/main" id="{E04E097A-6A4C-C7FD-0B8F-7D7AD2841014}"/>
               </a:ext>
             </a:extLst>
           </p:cNvPr>
@@ -10541,10 +10509,10 @@
       </p:sp>
       <p:pic>
         <p:nvPicPr>
-          <p:cNvPr id="5" name="Picture 4" descr="File:Jellyfin - icon-transparent.svg - Wikimedia Commons">
-            <a:extLst>
-              <a:ext uri="{FF2B5EF4-FFF2-40B4-BE49-F238E27FC236}">
-                <a16:creationId xmlns:a16="http://schemas.microsoft.com/office/drawing/2014/main" id="{5278FC50-B4EE-9AB9-FC49-4D658B53A9CC}"/>
+          <p:cNvPr id="5" name="Picture 4" descr="Disc HDd Hard Download HD Transparent HQ PNG Download | FreePNGimg">
+            <a:extLst>
+              <a:ext uri="{FF2B5EF4-FFF2-40B4-BE49-F238E27FC236}">
+                <a16:creationId xmlns:a16="http://schemas.microsoft.com/office/drawing/2014/main" id="{DBE3D5C7-A2F4-BAB3-652D-6A16C40993C2}"/>
               </a:ext>
             </a:extLst>
           </p:cNvPr>
@@ -10561,68 +10529,8 @@
         </p:blipFill>
         <p:spPr>
           <a:xfrm>
-            <a:off x="8008579" y="1815326"/>
-            <a:ext cx="1385558" cy="1385558"/>
-          </a:xfrm>
-          <a:prstGeom prst="rect">
-            <a:avLst/>
-          </a:prstGeom>
-        </p:spPr>
-      </p:pic>
-      <p:pic>
-        <p:nvPicPr>
-          <p:cNvPr id="6" name="Picture 5" descr="File:New qBittorrent Logo.svg - Wikimedia Commons">
-            <a:extLst>
-              <a:ext uri="{FF2B5EF4-FFF2-40B4-BE49-F238E27FC236}">
-                <a16:creationId xmlns:a16="http://schemas.microsoft.com/office/drawing/2014/main" id="{459FCE28-3F06-6D8F-6854-24B8B32BB612}"/>
-              </a:ext>
-            </a:extLst>
-          </p:cNvPr>
-          <p:cNvPicPr>
-            <a:picLocks noChangeAspect="1"/>
-          </p:cNvPicPr>
-          <p:nvPr/>
-        </p:nvPicPr>
-        <p:blipFill>
-          <a:blip r:embed="rId3"/>
-          <a:stretch>
-            <a:fillRect/>
-          </a:stretch>
-        </p:blipFill>
-        <p:spPr>
-          <a:xfrm>
-            <a:off x="8008578" y="3621508"/>
-            <a:ext cx="1385559" cy="1385559"/>
-          </a:xfrm>
-          <a:prstGeom prst="rect">
-            <a:avLst/>
-          </a:prstGeom>
-        </p:spPr>
-      </p:pic>
-      <p:pic>
-        <p:nvPicPr>
-          <p:cNvPr id="7" name="Picture 6" descr="GitHub - tteck/Proxmox: Proxmox VE Helper-Scripts · GitHub">
-            <a:extLst>
-              <a:ext uri="{FF2B5EF4-FFF2-40B4-BE49-F238E27FC236}">
-                <a16:creationId xmlns:a16="http://schemas.microsoft.com/office/drawing/2014/main" id="{897A21CE-79AF-2C77-EFDC-1B4A045D128D}"/>
-              </a:ext>
-            </a:extLst>
-          </p:cNvPr>
-          <p:cNvPicPr>
-            <a:picLocks noChangeAspect="1"/>
-          </p:cNvPicPr>
-          <p:nvPr/>
-        </p:nvPicPr>
-        <p:blipFill>
-          <a:blip r:embed="rId4"/>
-          <a:stretch>
-            <a:fillRect/>
-          </a:stretch>
-        </p:blipFill>
-        <p:spPr>
-          <a:xfrm>
-            <a:off x="8152805" y="5099384"/>
-            <a:ext cx="1097104" cy="1530016"/>
+            <a:off x="320559" y="3620792"/>
+            <a:ext cx="3164305" cy="2624560"/>
           </a:xfrm>
           <a:prstGeom prst="rect">
             <a:avLst/>
@@ -10632,7 +10540,7 @@
     </p:spTree>
     <p:extLst>
       <p:ext uri="{BB962C8B-B14F-4D97-AF65-F5344CB8AC3E}">
-        <p14:creationId xmlns:p14="http://schemas.microsoft.com/office/powerpoint/2010/main" val="933776943"/>
+        <p14:creationId xmlns:p14="http://schemas.microsoft.com/office/powerpoint/2010/main" val="3441423203"/>
       </p:ext>
     </p:extLst>
   </p:cSld>
@@ -10661,10 +10569,10 @@
       </p:grpSpPr>
       <p:sp>
         <p:nvSpPr>
-          <p:cNvPr id="4" name="Title 3">
-            <a:extLst>
-              <a:ext uri="{FF2B5EF4-FFF2-40B4-BE49-F238E27FC236}">
-                <a16:creationId xmlns:a16="http://schemas.microsoft.com/office/drawing/2014/main" id="{81E6FF2E-236F-3771-FCEE-54B694A348D7}"/>
+          <p:cNvPr id="2" name="Title 1">
+            <a:extLst>
+              <a:ext uri="{FF2B5EF4-FFF2-40B4-BE49-F238E27FC236}">
+                <a16:creationId xmlns:a16="http://schemas.microsoft.com/office/drawing/2014/main" id="{198C43F5-C69B-793B-9C6A-83C1F0823EEF}"/>
               </a:ext>
             </a:extLst>
           </p:cNvPr>
@@ -10681,25 +10589,27 @@
           <a:lstStyle/>
           <a:p>
             <a:r>
-              <a:rPr lang="en-US" dirty="0"/>
-              <a:t>79 MB/s Write</a:t>
-            </a:r>
-            <a:br>
-              <a:rPr lang="en-US" dirty="0"/>
-            </a:br>
-            <a:r>
-              <a:rPr lang="en-US" dirty="0"/>
-              <a:t>44 MB/s Read</a:t>
-            </a:r>
-          </a:p>
-        </p:txBody>
-      </p:sp>
-      <p:sp>
-        <p:nvSpPr>
-          <p:cNvPr id="5" name="Content Placeholder 4">
-            <a:extLst>
-              <a:ext uri="{FF2B5EF4-FFF2-40B4-BE49-F238E27FC236}">
-                <a16:creationId xmlns:a16="http://schemas.microsoft.com/office/drawing/2014/main" id="{0E3AF2CE-12BA-3C0E-2955-FA36D65340FB}"/>
+              <a:rPr lang="de-AT" noProof="0" dirty="0" err="1"/>
+              <a:t>Truenas</a:t>
+            </a:r>
+            <a:r>
+              <a:rPr lang="de-AT" noProof="0" dirty="0"/>
+              <a:t> </a:t>
+            </a:r>
+            <a:r>
+              <a:rPr lang="de-AT" noProof="0" dirty="0" err="1"/>
+              <a:t>COnfig</a:t>
+            </a:r>
+            <a:endParaRPr lang="de-AT" noProof="0" dirty="0"/>
+          </a:p>
+        </p:txBody>
+      </p:sp>
+      <p:sp>
+        <p:nvSpPr>
+          <p:cNvPr id="3" name="Content Placeholder 2">
+            <a:extLst>
+              <a:ext uri="{FF2B5EF4-FFF2-40B4-BE49-F238E27FC236}">
+                <a16:creationId xmlns:a16="http://schemas.microsoft.com/office/drawing/2014/main" id="{13A11DA4-EB64-9E64-4B8F-C7AD9A563651}"/>
               </a:ext>
             </a:extLst>
           </p:cNvPr>
@@ -10716,69 +10626,66 @@
           <a:lstStyle/>
           <a:p>
             <a:r>
-              <a:rPr lang="en-US" dirty="0" err="1"/>
-              <a:t>Im</a:t>
-            </a:r>
-            <a:r>
-              <a:rPr lang="en-US" dirty="0"/>
-              <a:t> A-Netz </a:t>
-            </a:r>
-            <a:r>
-              <a:rPr lang="en-US" dirty="0" err="1"/>
-              <a:t>gemessen</a:t>
-            </a:r>
-            <a:endParaRPr lang="en-US" dirty="0"/>
-          </a:p>
-          <a:p>
-            <a:r>
-              <a:rPr lang="en-US" dirty="0"/>
-              <a:t>Switch hat 100 MB/s</a:t>
-            </a:r>
-          </a:p>
-          <a:p>
-            <a:r>
-              <a:rPr lang="en-US" dirty="0"/>
-              <a:t>dd if=/dev/zero of=</a:t>
-            </a:r>
-            <a:r>
-              <a:rPr lang="en-US" dirty="0" err="1"/>
-              <a:t>testdatei</a:t>
-            </a:r>
-            <a:r>
-              <a:rPr lang="en-US" dirty="0"/>
-              <a:t> bs=1M count=1024 conv=</a:t>
-            </a:r>
-            <a:r>
-              <a:rPr lang="en-US" dirty="0" err="1"/>
-              <a:t>fdatasync</a:t>
-            </a:r>
-            <a:r>
-              <a:rPr lang="en-US" dirty="0"/>
-              <a:t> status=progress</a:t>
-            </a:r>
-          </a:p>
-          <a:p>
-            <a:r>
-              <a:rPr lang="en-US" dirty="0"/>
-              <a:t>dd if=</a:t>
-            </a:r>
-            <a:r>
-              <a:rPr lang="en-US" dirty="0" err="1"/>
-              <a:t>testdatei</a:t>
-            </a:r>
-            <a:r>
-              <a:rPr lang="en-US" dirty="0"/>
-              <a:t> of=/dev/null bs=1M status=progress</a:t>
-            </a:r>
-          </a:p>
-        </p:txBody>
-      </p:sp>
-      <p:sp>
-        <p:nvSpPr>
-          <p:cNvPr id="6" name="Slide Number Placeholder 5">
-            <a:extLst>
-              <a:ext uri="{FF2B5EF4-FFF2-40B4-BE49-F238E27FC236}">
-                <a16:creationId xmlns:a16="http://schemas.microsoft.com/office/drawing/2014/main" id="{8CBDED7D-0DCF-8C4D-542B-17626248FC92}"/>
+              <a:rPr lang="de-AT" noProof="0" dirty="0"/>
+              <a:t>ZFS Pool (2x320GB HDD)</a:t>
+            </a:r>
+          </a:p>
+          <a:p>
+            <a:r>
+              <a:rPr lang="de-AT" noProof="0" dirty="0"/>
+              <a:t>Eigene Datasets jeweils für Fronthaler, Glatz, </a:t>
+            </a:r>
+            <a:r>
+              <a:rPr lang="de-AT" noProof="0" dirty="0" err="1"/>
+              <a:t>Signitzer</a:t>
+            </a:r>
+            <a:endParaRPr lang="de-AT" noProof="0" dirty="0"/>
+          </a:p>
+          <a:p>
+            <a:r>
+              <a:rPr lang="de-AT" noProof="0" dirty="0" err="1"/>
+              <a:t>Shared</a:t>
+            </a:r>
+            <a:r>
+              <a:rPr lang="de-AT" noProof="0" dirty="0"/>
+              <a:t> Dataset für alle</a:t>
+            </a:r>
+          </a:p>
+          <a:p>
+            <a:r>
+              <a:rPr lang="de-AT" noProof="0" dirty="0"/>
+              <a:t>SMB und NFS Share (/</a:t>
+            </a:r>
+            <a:r>
+              <a:rPr lang="de-AT" noProof="0" dirty="0" err="1"/>
+              <a:t>mnt</a:t>
+            </a:r>
+            <a:r>
+              <a:rPr lang="de-AT" noProof="0" dirty="0"/>
+              <a:t>/DATA/…) eingerichtet</a:t>
+            </a:r>
+          </a:p>
+          <a:p>
+            <a:pPr lvl="1"/>
+            <a:endParaRPr lang="de-AT" noProof="0" dirty="0"/>
+          </a:p>
+          <a:p>
+            <a:endParaRPr lang="de-AT" noProof="0" dirty="0"/>
+          </a:p>
+          <a:p>
+            <a:endParaRPr lang="de-AT" noProof="0" dirty="0"/>
+          </a:p>
+          <a:p>
+            <a:endParaRPr lang="de-AT" noProof="0" dirty="0"/>
+          </a:p>
+        </p:txBody>
+      </p:sp>
+      <p:sp>
+        <p:nvSpPr>
+          <p:cNvPr id="4" name="Slide Number Placeholder 3">
+            <a:extLst>
+              <a:ext uri="{FF2B5EF4-FFF2-40B4-BE49-F238E27FC236}">
+                <a16:creationId xmlns:a16="http://schemas.microsoft.com/office/drawing/2014/main" id="{65D87626-8F8F-0CF7-FEB9-783E0646F45E}"/>
               </a:ext>
             </a:extLst>
           </p:cNvPr>
@@ -10802,10 +10709,40 @@
           </a:p>
         </p:txBody>
       </p:sp>
+      <p:pic>
+        <p:nvPicPr>
+          <p:cNvPr id="5" name="Picture 4" descr="Samba Server Icon &amp; Logo | Dashboard Icons &amp; Logos">
+            <a:extLst>
+              <a:ext uri="{FF2B5EF4-FFF2-40B4-BE49-F238E27FC236}">
+                <a16:creationId xmlns:a16="http://schemas.microsoft.com/office/drawing/2014/main" id="{FA8B58A0-E126-4A12-B4B9-79576B801716}"/>
+              </a:ext>
+            </a:extLst>
+          </p:cNvPr>
+          <p:cNvPicPr>
+            <a:picLocks noChangeAspect="1"/>
+          </p:cNvPicPr>
+          <p:nvPr/>
+        </p:nvPicPr>
+        <p:blipFill>
+          <a:blip r:embed="rId2"/>
+          <a:stretch>
+            <a:fillRect/>
+          </a:stretch>
+        </p:blipFill>
+        <p:spPr>
+          <a:xfrm>
+            <a:off x="405226" y="4437116"/>
+            <a:ext cx="1772490" cy="1614795"/>
+          </a:xfrm>
+          <a:prstGeom prst="rect">
+            <a:avLst/>
+          </a:prstGeom>
+        </p:spPr>
+      </p:pic>
     </p:spTree>
     <p:extLst>
       <p:ext uri="{BB962C8B-B14F-4D97-AF65-F5344CB8AC3E}">
-        <p14:creationId xmlns:p14="http://schemas.microsoft.com/office/powerpoint/2010/main" val="375118000"/>
+        <p14:creationId xmlns:p14="http://schemas.microsoft.com/office/powerpoint/2010/main" val="1726425326"/>
       </p:ext>
     </p:extLst>
   </p:cSld>
@@ -10834,6 +10771,462 @@
       </p:grpSpPr>
       <p:sp>
         <p:nvSpPr>
+          <p:cNvPr id="2" name="Title 1">
+            <a:extLst>
+              <a:ext uri="{FF2B5EF4-FFF2-40B4-BE49-F238E27FC236}">
+                <a16:creationId xmlns:a16="http://schemas.microsoft.com/office/drawing/2014/main" id="{E265C372-F4F4-7A48-C4F2-7B5F5366A619}"/>
+              </a:ext>
+            </a:extLst>
+          </p:cNvPr>
+          <p:cNvSpPr>
+            <a:spLocks noGrp="1"/>
+          </p:cNvSpPr>
+          <p:nvPr>
+            <p:ph type="title"/>
+          </p:nvPr>
+        </p:nvSpPr>
+        <p:spPr/>
+        <p:txBody>
+          <a:bodyPr/>
+          <a:lstStyle/>
+          <a:p>
+            <a:r>
+              <a:rPr lang="de-AT" noProof="0" dirty="0"/>
+              <a:t>Services</a:t>
+            </a:r>
+          </a:p>
+        </p:txBody>
+      </p:sp>
+      <p:sp>
+        <p:nvSpPr>
+          <p:cNvPr id="3" name="Content Placeholder 2">
+            <a:extLst>
+              <a:ext uri="{FF2B5EF4-FFF2-40B4-BE49-F238E27FC236}">
+                <a16:creationId xmlns:a16="http://schemas.microsoft.com/office/drawing/2014/main" id="{9FB4E924-E1ED-52CE-B3E9-DA9A879DC1C3}"/>
+              </a:ext>
+            </a:extLst>
+          </p:cNvPr>
+          <p:cNvSpPr>
+            <a:spLocks noGrp="1"/>
+          </p:cNvSpPr>
+          <p:nvPr>
+            <p:ph idx="1"/>
+          </p:nvPr>
+        </p:nvSpPr>
+        <p:spPr/>
+        <p:txBody>
+          <a:bodyPr/>
+          <a:lstStyle/>
+          <a:p>
+            <a:r>
+              <a:rPr lang="de-AT" noProof="0" dirty="0" err="1"/>
+              <a:t>Jellyfin</a:t>
+            </a:r>
+            <a:r>
+              <a:rPr lang="de-AT" noProof="0" dirty="0"/>
+              <a:t> </a:t>
+            </a:r>
+          </a:p>
+          <a:p>
+            <a:pPr lvl="1"/>
+            <a:r>
+              <a:rPr lang="de-AT" noProof="0" dirty="0" err="1"/>
+              <a:t>Unpriviledged</a:t>
+            </a:r>
+            <a:r>
+              <a:rPr lang="de-AT" noProof="0" dirty="0"/>
+              <a:t> LXC </a:t>
+            </a:r>
+            <a:r>
+              <a:rPr lang="de-AT" noProof="0" dirty="0" err="1"/>
+              <a:t>container</a:t>
+            </a:r>
+            <a:endParaRPr lang="de-AT" noProof="0" dirty="0"/>
+          </a:p>
+          <a:p>
+            <a:pPr lvl="1"/>
+            <a:r>
+              <a:rPr lang="de-AT" noProof="0" dirty="0"/>
+              <a:t>Um auf die Festplatten zugreifen zu können braucht es extra Zugriffsrechte</a:t>
+            </a:r>
+          </a:p>
+          <a:p>
+            <a:pPr marL="457200" lvl="1" indent="0">
+              <a:buNone/>
+            </a:pPr>
+            <a:endParaRPr lang="de-AT" noProof="0" dirty="0"/>
+          </a:p>
+          <a:p>
+            <a:r>
+              <a:rPr lang="de-AT" noProof="0" dirty="0" err="1"/>
+              <a:t>qBittorrent</a:t>
+            </a:r>
+            <a:endParaRPr lang="de-AT" noProof="0" dirty="0"/>
+          </a:p>
+          <a:p>
+            <a:pPr lvl="1"/>
+            <a:r>
+              <a:rPr lang="de-AT" noProof="0" dirty="0" err="1"/>
+              <a:t>Unpriviledged</a:t>
+            </a:r>
+            <a:r>
+              <a:rPr lang="de-AT" noProof="0" dirty="0"/>
+              <a:t> LXC </a:t>
+            </a:r>
+            <a:r>
+              <a:rPr lang="de-AT" noProof="0" dirty="0" err="1"/>
+              <a:t>container</a:t>
+            </a:r>
+            <a:endParaRPr lang="de-AT" noProof="0" dirty="0"/>
+          </a:p>
+          <a:p>
+            <a:pPr lvl="1"/>
+            <a:r>
+              <a:rPr lang="de-AT" noProof="0" dirty="0"/>
+              <a:t>Torrenten im Schulnetz geblockt</a:t>
+            </a:r>
+          </a:p>
+          <a:p>
+            <a:pPr marL="457200" lvl="1" indent="0">
+              <a:buNone/>
+            </a:pPr>
+            <a:endParaRPr lang="de-AT" noProof="0" dirty="0"/>
+          </a:p>
+          <a:p>
+            <a:r>
+              <a:rPr lang="de-AT" noProof="0" dirty="0"/>
+              <a:t>Installiert mit Helper Scripts</a:t>
+            </a:r>
+          </a:p>
+          <a:p>
+            <a:endParaRPr lang="de-AT" noProof="0" dirty="0"/>
+          </a:p>
+        </p:txBody>
+      </p:sp>
+      <p:sp>
+        <p:nvSpPr>
+          <p:cNvPr id="4" name="Slide Number Placeholder 3">
+            <a:extLst>
+              <a:ext uri="{FF2B5EF4-FFF2-40B4-BE49-F238E27FC236}">
+                <a16:creationId xmlns:a16="http://schemas.microsoft.com/office/drawing/2014/main" id="{A299164C-61EF-39D0-FC1D-32FC00147B09}"/>
+              </a:ext>
+            </a:extLst>
+          </p:cNvPr>
+          <p:cNvSpPr>
+            <a:spLocks noGrp="1"/>
+          </p:cNvSpPr>
+          <p:nvPr>
+            <p:ph type="sldNum" sz="quarter" idx="12"/>
+          </p:nvPr>
+        </p:nvSpPr>
+        <p:spPr/>
+        <p:txBody>
+          <a:bodyPr/>
+          <a:lstStyle/>
+          <a:p>
+            <a:fld id="{C0D0E01E-7608-4E47-B545-5FF4C235404B}" type="slidenum">
+              <a:rPr lang="en-US" smtClean="0"/>
+              <a:t>13</a:t>
+            </a:fld>
+            <a:endParaRPr lang="en-US"/>
+          </a:p>
+        </p:txBody>
+      </p:sp>
+      <p:pic>
+        <p:nvPicPr>
+          <p:cNvPr id="5" name="Picture 4" descr="File:Jellyfin - icon-transparent.svg - Wikimedia Commons">
+            <a:extLst>
+              <a:ext uri="{FF2B5EF4-FFF2-40B4-BE49-F238E27FC236}">
+                <a16:creationId xmlns:a16="http://schemas.microsoft.com/office/drawing/2014/main" id="{5278FC50-B4EE-9AB9-FC49-4D658B53A9CC}"/>
+              </a:ext>
+            </a:extLst>
+          </p:cNvPr>
+          <p:cNvPicPr>
+            <a:picLocks noChangeAspect="1"/>
+          </p:cNvPicPr>
+          <p:nvPr/>
+        </p:nvPicPr>
+        <p:blipFill>
+          <a:blip r:embed="rId2"/>
+          <a:stretch>
+            <a:fillRect/>
+          </a:stretch>
+        </p:blipFill>
+        <p:spPr>
+          <a:xfrm>
+            <a:off x="8008579" y="1815326"/>
+            <a:ext cx="1385558" cy="1385558"/>
+          </a:xfrm>
+          <a:prstGeom prst="rect">
+            <a:avLst/>
+          </a:prstGeom>
+        </p:spPr>
+      </p:pic>
+      <p:pic>
+        <p:nvPicPr>
+          <p:cNvPr id="6" name="Picture 5" descr="File:New qBittorrent Logo.svg - Wikimedia Commons">
+            <a:extLst>
+              <a:ext uri="{FF2B5EF4-FFF2-40B4-BE49-F238E27FC236}">
+                <a16:creationId xmlns:a16="http://schemas.microsoft.com/office/drawing/2014/main" id="{459FCE28-3F06-6D8F-6854-24B8B32BB612}"/>
+              </a:ext>
+            </a:extLst>
+          </p:cNvPr>
+          <p:cNvPicPr>
+            <a:picLocks noChangeAspect="1"/>
+          </p:cNvPicPr>
+          <p:nvPr/>
+        </p:nvPicPr>
+        <p:blipFill>
+          <a:blip r:embed="rId3"/>
+          <a:stretch>
+            <a:fillRect/>
+          </a:stretch>
+        </p:blipFill>
+        <p:spPr>
+          <a:xfrm>
+            <a:off x="8008578" y="3621508"/>
+            <a:ext cx="1385559" cy="1385559"/>
+          </a:xfrm>
+          <a:prstGeom prst="rect">
+            <a:avLst/>
+          </a:prstGeom>
+        </p:spPr>
+      </p:pic>
+      <p:pic>
+        <p:nvPicPr>
+          <p:cNvPr id="7" name="Picture 6" descr="GitHub - tteck/Proxmox: Proxmox VE Helper-Scripts · GitHub">
+            <a:extLst>
+              <a:ext uri="{FF2B5EF4-FFF2-40B4-BE49-F238E27FC236}">
+                <a16:creationId xmlns:a16="http://schemas.microsoft.com/office/drawing/2014/main" id="{897A21CE-79AF-2C77-EFDC-1B4A045D128D}"/>
+              </a:ext>
+            </a:extLst>
+          </p:cNvPr>
+          <p:cNvPicPr>
+            <a:picLocks noChangeAspect="1"/>
+          </p:cNvPicPr>
+          <p:nvPr/>
+        </p:nvPicPr>
+        <p:blipFill>
+          <a:blip r:embed="rId4"/>
+          <a:stretch>
+            <a:fillRect/>
+          </a:stretch>
+        </p:blipFill>
+        <p:spPr>
+          <a:xfrm>
+            <a:off x="8152805" y="5099384"/>
+            <a:ext cx="1097104" cy="1530016"/>
+          </a:xfrm>
+          <a:prstGeom prst="rect">
+            <a:avLst/>
+          </a:prstGeom>
+        </p:spPr>
+      </p:pic>
+    </p:spTree>
+    <p:extLst>
+      <p:ext uri="{BB962C8B-B14F-4D97-AF65-F5344CB8AC3E}">
+        <p14:creationId xmlns:p14="http://schemas.microsoft.com/office/powerpoint/2010/main" val="933776943"/>
+      </p:ext>
+    </p:extLst>
+  </p:cSld>
+  <p:clrMapOvr>
+    <a:masterClrMapping/>
+  </p:clrMapOvr>
+</p:sld>
+</file>
+
+<file path=ppt/slides/slide14.xml><?xml version="1.0" encoding="utf-8"?>
+<p:sld xmlns:a="http://schemas.openxmlformats.org/drawingml/2006/main" xmlns:r="http://schemas.openxmlformats.org/officeDocument/2006/relationships" xmlns:p="http://schemas.openxmlformats.org/presentationml/2006/main">
+  <p:cSld>
+    <p:spTree>
+      <p:nvGrpSpPr>
+        <p:cNvPr id="1" name=""/>
+        <p:cNvGrpSpPr/>
+        <p:nvPr/>
+      </p:nvGrpSpPr>
+      <p:grpSpPr>
+        <a:xfrm>
+          <a:off x="0" y="0"/>
+          <a:ext cx="0" cy="0"/>
+          <a:chOff x="0" y="0"/>
+          <a:chExt cx="0" cy="0"/>
+        </a:xfrm>
+      </p:grpSpPr>
+      <p:sp>
+        <p:nvSpPr>
+          <p:cNvPr id="4" name="Title 3">
+            <a:extLst>
+              <a:ext uri="{FF2B5EF4-FFF2-40B4-BE49-F238E27FC236}">
+                <a16:creationId xmlns:a16="http://schemas.microsoft.com/office/drawing/2014/main" id="{81E6FF2E-236F-3771-FCEE-54B694A348D7}"/>
+              </a:ext>
+            </a:extLst>
+          </p:cNvPr>
+          <p:cNvSpPr>
+            <a:spLocks noGrp="1"/>
+          </p:cNvSpPr>
+          <p:nvPr>
+            <p:ph type="title"/>
+          </p:nvPr>
+        </p:nvSpPr>
+        <p:spPr/>
+        <p:txBody>
+          <a:bodyPr/>
+          <a:lstStyle/>
+          <a:p>
+            <a:r>
+              <a:rPr lang="en-US" dirty="0"/>
+              <a:t>79 MB/s Write</a:t>
+            </a:r>
+            <a:br>
+              <a:rPr lang="en-US" dirty="0"/>
+            </a:br>
+            <a:r>
+              <a:rPr lang="en-US" dirty="0"/>
+              <a:t>44 MB/s Read</a:t>
+            </a:r>
+          </a:p>
+        </p:txBody>
+      </p:sp>
+      <p:sp>
+        <p:nvSpPr>
+          <p:cNvPr id="5" name="Content Placeholder 4">
+            <a:extLst>
+              <a:ext uri="{FF2B5EF4-FFF2-40B4-BE49-F238E27FC236}">
+                <a16:creationId xmlns:a16="http://schemas.microsoft.com/office/drawing/2014/main" id="{0E3AF2CE-12BA-3C0E-2955-FA36D65340FB}"/>
+              </a:ext>
+            </a:extLst>
+          </p:cNvPr>
+          <p:cNvSpPr>
+            <a:spLocks noGrp="1"/>
+          </p:cNvSpPr>
+          <p:nvPr>
+            <p:ph idx="1"/>
+          </p:nvPr>
+        </p:nvSpPr>
+        <p:spPr/>
+        <p:txBody>
+          <a:bodyPr/>
+          <a:lstStyle/>
+          <a:p>
+            <a:r>
+              <a:rPr lang="en-US" dirty="0" err="1"/>
+              <a:t>Im</a:t>
+            </a:r>
+            <a:r>
+              <a:rPr lang="en-US" dirty="0"/>
+              <a:t> A-Netz </a:t>
+            </a:r>
+            <a:r>
+              <a:rPr lang="en-US" dirty="0" err="1"/>
+              <a:t>gemessen</a:t>
+            </a:r>
+            <a:endParaRPr lang="en-US" dirty="0"/>
+          </a:p>
+          <a:p>
+            <a:r>
+              <a:rPr lang="en-US" dirty="0"/>
+              <a:t>Switch hat 100 MB/s</a:t>
+            </a:r>
+          </a:p>
+          <a:p>
+            <a:r>
+              <a:rPr lang="en-US" dirty="0"/>
+              <a:t>dd if=/dev/zero of=</a:t>
+            </a:r>
+            <a:r>
+              <a:rPr lang="en-US" dirty="0" err="1"/>
+              <a:t>testdatei</a:t>
+            </a:r>
+            <a:r>
+              <a:rPr lang="en-US" dirty="0"/>
+              <a:t> bs=1M count=1024 conv=</a:t>
+            </a:r>
+            <a:r>
+              <a:rPr lang="en-US" dirty="0" err="1"/>
+              <a:t>fdatasync</a:t>
+            </a:r>
+            <a:r>
+              <a:rPr lang="en-US" dirty="0"/>
+              <a:t> status=progress</a:t>
+            </a:r>
+          </a:p>
+          <a:p>
+            <a:r>
+              <a:rPr lang="en-US" dirty="0"/>
+              <a:t>dd if=</a:t>
+            </a:r>
+            <a:r>
+              <a:rPr lang="en-US" dirty="0" err="1"/>
+              <a:t>testdatei</a:t>
+            </a:r>
+            <a:r>
+              <a:rPr lang="en-US" dirty="0"/>
+              <a:t> of=/dev/null bs=1M status=progress</a:t>
+            </a:r>
+          </a:p>
+        </p:txBody>
+      </p:sp>
+      <p:sp>
+        <p:nvSpPr>
+          <p:cNvPr id="6" name="Slide Number Placeholder 5">
+            <a:extLst>
+              <a:ext uri="{FF2B5EF4-FFF2-40B4-BE49-F238E27FC236}">
+                <a16:creationId xmlns:a16="http://schemas.microsoft.com/office/drawing/2014/main" id="{8CBDED7D-0DCF-8C4D-542B-17626248FC92}"/>
+              </a:ext>
+            </a:extLst>
+          </p:cNvPr>
+          <p:cNvSpPr>
+            <a:spLocks noGrp="1"/>
+          </p:cNvSpPr>
+          <p:nvPr>
+            <p:ph type="sldNum" sz="quarter" idx="12"/>
+          </p:nvPr>
+        </p:nvSpPr>
+        <p:spPr/>
+        <p:txBody>
+          <a:bodyPr/>
+          <a:lstStyle/>
+          <a:p>
+            <a:fld id="{C0D0E01E-7608-4E47-B545-5FF4C235404B}" type="slidenum">
+              <a:rPr lang="en-US" smtClean="0"/>
+              <a:t>14</a:t>
+            </a:fld>
+            <a:endParaRPr lang="en-US"/>
+          </a:p>
+        </p:txBody>
+      </p:sp>
+    </p:spTree>
+    <p:extLst>
+      <p:ext uri="{BB962C8B-B14F-4D97-AF65-F5344CB8AC3E}">
+        <p14:creationId xmlns:p14="http://schemas.microsoft.com/office/powerpoint/2010/main" val="375118000"/>
+      </p:ext>
+    </p:extLst>
+  </p:cSld>
+  <p:clrMapOvr>
+    <a:masterClrMapping/>
+  </p:clrMapOvr>
+</p:sld>
+</file>
+
+<file path=ppt/slides/slide15.xml><?xml version="1.0" encoding="utf-8"?>
+<p:sld xmlns:a="http://schemas.openxmlformats.org/drawingml/2006/main" xmlns:r="http://schemas.openxmlformats.org/officeDocument/2006/relationships" xmlns:p="http://schemas.openxmlformats.org/presentationml/2006/main">
+  <p:cSld>
+    <p:spTree>
+      <p:nvGrpSpPr>
+        <p:cNvPr id="1" name=""/>
+        <p:cNvGrpSpPr/>
+        <p:nvPr/>
+      </p:nvGrpSpPr>
+      <p:grpSpPr>
+        <a:xfrm>
+          <a:off x="0" y="0"/>
+          <a:ext cx="0" cy="0"/>
+          <a:chOff x="0" y="0"/>
+          <a:chExt cx="0" cy="0"/>
+        </a:xfrm>
+      </p:grpSpPr>
+      <p:sp>
+        <p:nvSpPr>
           <p:cNvPr id="4" name="Title 3">
             <a:extLst>
               <a:ext uri="{FF2B5EF4-FFF2-40B4-BE49-F238E27FC236}">
@@ -11275,7 +11668,7 @@
           <a:p>
             <a:fld id="{C0D0E01E-7608-4E47-B545-5FF4C235404B}" type="slidenum">
               <a:rPr lang="en-US" smtClean="0"/>
-              <a:t>13</a:t>
+              <a:t>15</a:t>
             </a:fld>
             <a:endParaRPr lang="en-US"/>
           </a:p>
@@ -11313,10 +11706,10 @@
       </p:grpSpPr>
       <p:sp>
         <p:nvSpPr>
-          <p:cNvPr id="5" name="Title 4">
-            <a:extLst>
-              <a:ext uri="{FF2B5EF4-FFF2-40B4-BE49-F238E27FC236}">
-                <a16:creationId xmlns:a16="http://schemas.microsoft.com/office/drawing/2014/main" id="{C457BB94-6C0B-0068-D8BB-722CFD7AC18B}"/>
+          <p:cNvPr id="4" name="Title 3">
+            <a:extLst>
+              <a:ext uri="{FF2B5EF4-FFF2-40B4-BE49-F238E27FC236}">
+                <a16:creationId xmlns:a16="http://schemas.microsoft.com/office/drawing/2014/main" id="{F02B2A6D-D443-64DF-A247-E4AA331BF69F}"/>
               </a:ext>
             </a:extLst>
           </p:cNvPr>
@@ -11333,34 +11726,18 @@
           <a:lstStyle/>
           <a:p>
             <a:r>
-              <a:rPr lang="en-US" dirty="0"/>
-              <a:t>WAS </a:t>
-            </a:r>
-            <a:r>
-              <a:rPr lang="en-US" dirty="0" err="1"/>
-              <a:t>ist</a:t>
-            </a:r>
-            <a:r>
-              <a:rPr lang="en-US" dirty="0"/>
-              <a:t> </a:t>
-            </a:r>
-            <a:r>
-              <a:rPr lang="en-US" dirty="0" err="1"/>
-              <a:t>ein</a:t>
-            </a:r>
-            <a:r>
-              <a:rPr lang="en-US" dirty="0"/>
-              <a:t> NAS?</a:t>
-            </a:r>
-          </a:p>
-        </p:txBody>
-      </p:sp>
-      <p:sp>
-        <p:nvSpPr>
-          <p:cNvPr id="6" name="Content Placeholder 5">
-            <a:extLst>
-              <a:ext uri="{FF2B5EF4-FFF2-40B4-BE49-F238E27FC236}">
-                <a16:creationId xmlns:a16="http://schemas.microsoft.com/office/drawing/2014/main" id="{FF6C7CA8-F903-8D6C-B9C8-C5B94D75DD58}"/>
+              <a:rPr lang="de-AT" dirty="0"/>
+              <a:t>Inhaltsangabe</a:t>
+            </a:r>
+          </a:p>
+        </p:txBody>
+      </p:sp>
+      <p:sp>
+        <p:nvSpPr>
+          <p:cNvPr id="5" name="Content Placeholder 4">
+            <a:extLst>
+              <a:ext uri="{FF2B5EF4-FFF2-40B4-BE49-F238E27FC236}">
+                <a16:creationId xmlns:a16="http://schemas.microsoft.com/office/drawing/2014/main" id="{A7222352-63ED-3606-B9DE-7D12CBFE32A4}"/>
               </a:ext>
             </a:extLst>
           </p:cNvPr>
@@ -11377,46 +11754,42 @@
           <a:lstStyle/>
           <a:p>
             <a:r>
-              <a:rPr lang="en-US" dirty="0"/>
-              <a:t>Network attached storage</a:t>
-            </a:r>
-          </a:p>
-          <a:p>
-            <a:r>
-              <a:rPr lang="en-US" dirty="0" err="1"/>
-              <a:t>Datenserver</a:t>
-            </a:r>
-            <a:endParaRPr lang="en-US" dirty="0"/>
-          </a:p>
-          <a:p>
-            <a:r>
-              <a:rPr lang="en-US" dirty="0"/>
-              <a:t>Backups</a:t>
-            </a:r>
-          </a:p>
-          <a:p>
-            <a:r>
-              <a:rPr lang="en-US"/>
-              <a:t>Raid-Systeme</a:t>
-            </a:r>
-          </a:p>
-          <a:p>
-            <a:pPr marL="0" indent="0">
-              <a:buNone/>
-            </a:pPr>
-            <a:endParaRPr lang="en-US" dirty="0"/>
-          </a:p>
-          <a:p>
-            <a:endParaRPr lang="en-US" dirty="0"/>
-          </a:p>
-        </p:txBody>
-      </p:sp>
-      <p:sp>
-        <p:nvSpPr>
-          <p:cNvPr id="4" name="Slide Number Placeholder 3">
-            <a:extLst>
-              <a:ext uri="{FF2B5EF4-FFF2-40B4-BE49-F238E27FC236}">
-                <a16:creationId xmlns:a16="http://schemas.microsoft.com/office/drawing/2014/main" id="{4470938F-136B-B9F6-54AB-E2D6EA017CEB}"/>
+              <a:rPr lang="de-AT"/>
+              <a:t>Was ist ein NAS?</a:t>
+            </a:r>
+          </a:p>
+          <a:p>
+            <a:r>
+              <a:rPr lang="de-AT"/>
+              <a:t>Anforderungen und Ziele</a:t>
+            </a:r>
+          </a:p>
+          <a:p>
+            <a:r>
+              <a:rPr lang="de-AT"/>
+              <a:t>DIY und Fertig-NAS: Kostenvergleich</a:t>
+            </a:r>
+          </a:p>
+          <a:p>
+            <a:r>
+              <a:rPr lang="de-AT"/>
+              <a:t>DIY und Fertig-NAS: Funktionen und Erweiterung</a:t>
+            </a:r>
+          </a:p>
+          <a:p>
+            <a:r>
+              <a:rPr lang="de-AT"/>
+              <a:t>Unsere Hardware</a:t>
+            </a:r>
+          </a:p>
+        </p:txBody>
+      </p:sp>
+      <p:sp>
+        <p:nvSpPr>
+          <p:cNvPr id="6" name="Slide Number Placeholder 5">
+            <a:extLst>
+              <a:ext uri="{FF2B5EF4-FFF2-40B4-BE49-F238E27FC236}">
+                <a16:creationId xmlns:a16="http://schemas.microsoft.com/office/drawing/2014/main" id="{9000D2D5-FD9B-60A1-E0C0-390C58C1CC00}"/>
               </a:ext>
             </a:extLst>
           </p:cNvPr>
@@ -11440,40 +11813,10 @@
           </a:p>
         </p:txBody>
       </p:sp>
-      <p:pic>
-        <p:nvPicPr>
-          <p:cNvPr id="7" name="Picture 6">
-            <a:extLst>
-              <a:ext uri="{FF2B5EF4-FFF2-40B4-BE49-F238E27FC236}">
-                <a16:creationId xmlns:a16="http://schemas.microsoft.com/office/drawing/2014/main" id="{B9F91517-9BBE-15B6-1A7D-20ABB2EE121D}"/>
-              </a:ext>
-            </a:extLst>
-          </p:cNvPr>
-          <p:cNvPicPr>
-            <a:picLocks noChangeAspect="1"/>
-          </p:cNvPicPr>
-          <p:nvPr/>
-        </p:nvPicPr>
-        <p:blipFill>
-          <a:blip r:embed="rId2"/>
-          <a:stretch>
-            <a:fillRect/>
-          </a:stretch>
-        </p:blipFill>
-        <p:spPr>
-          <a:xfrm>
-            <a:off x="7452227" y="1743964"/>
-            <a:ext cx="4241800" cy="2540000"/>
-          </a:xfrm>
-          <a:prstGeom prst="rect">
-            <a:avLst/>
-          </a:prstGeom>
-        </p:spPr>
-      </p:pic>
     </p:spTree>
     <p:extLst>
       <p:ext uri="{BB962C8B-B14F-4D97-AF65-F5344CB8AC3E}">
-        <p14:creationId xmlns:p14="http://schemas.microsoft.com/office/powerpoint/2010/main" val="1373828103"/>
+        <p14:creationId xmlns:p14="http://schemas.microsoft.com/office/powerpoint/2010/main" val="3293452096"/>
       </p:ext>
     </p:extLst>
   </p:cSld>
@@ -11502,10 +11845,10 @@
       </p:grpSpPr>
       <p:sp>
         <p:nvSpPr>
-          <p:cNvPr id="4" name="Title 3">
-            <a:extLst>
-              <a:ext uri="{FF2B5EF4-FFF2-40B4-BE49-F238E27FC236}">
-                <a16:creationId xmlns:a16="http://schemas.microsoft.com/office/drawing/2014/main" id="{F02B2A6D-D443-64DF-A247-E4AA331BF69F}"/>
+          <p:cNvPr id="5" name="Title 4">
+            <a:extLst>
+              <a:ext uri="{FF2B5EF4-FFF2-40B4-BE49-F238E27FC236}">
+                <a16:creationId xmlns:a16="http://schemas.microsoft.com/office/drawing/2014/main" id="{C457BB94-6C0B-0068-D8BB-722CFD7AC18B}"/>
               </a:ext>
             </a:extLst>
           </p:cNvPr>
@@ -11522,18 +11865,34 @@
           <a:lstStyle/>
           <a:p>
             <a:r>
-              <a:rPr lang="de-AT" noProof="0" dirty="0"/>
-              <a:t>Anforderungen / Ziele</a:t>
-            </a:r>
-          </a:p>
-        </p:txBody>
-      </p:sp>
-      <p:sp>
-        <p:nvSpPr>
-          <p:cNvPr id="5" name="Content Placeholder 4">
-            <a:extLst>
-              <a:ext uri="{FF2B5EF4-FFF2-40B4-BE49-F238E27FC236}">
-                <a16:creationId xmlns:a16="http://schemas.microsoft.com/office/drawing/2014/main" id="{A7222352-63ED-3606-B9DE-7D12CBFE32A4}"/>
+              <a:rPr lang="en-US" dirty="0"/>
+              <a:t>WAS </a:t>
+            </a:r>
+            <a:r>
+              <a:rPr lang="en-US" dirty="0" err="1"/>
+              <a:t>ist</a:t>
+            </a:r>
+            <a:r>
+              <a:rPr lang="en-US" dirty="0"/>
+              <a:t> </a:t>
+            </a:r>
+            <a:r>
+              <a:rPr lang="en-US" dirty="0" err="1"/>
+              <a:t>ein</a:t>
+            </a:r>
+            <a:r>
+              <a:rPr lang="en-US" dirty="0"/>
+              <a:t> NAS?</a:t>
+            </a:r>
+          </a:p>
+        </p:txBody>
+      </p:sp>
+      <p:sp>
+        <p:nvSpPr>
+          <p:cNvPr id="6" name="Content Placeholder 5">
+            <a:extLst>
+              <a:ext uri="{FF2B5EF4-FFF2-40B4-BE49-F238E27FC236}">
+                <a16:creationId xmlns:a16="http://schemas.microsoft.com/office/drawing/2014/main" id="{FF6C7CA8-F903-8D6C-B9C8-C5B94D75DD58}"/>
               </a:ext>
             </a:extLst>
           </p:cNvPr>
@@ -11550,61 +11909,46 @@
           <a:lstStyle/>
           <a:p>
             <a:r>
-              <a:rPr lang="de-AT" noProof="0" dirty="0"/>
-              <a:t>Mehrere User mit eigenen Privaten Ordnern</a:t>
-            </a:r>
-          </a:p>
-          <a:p>
-            <a:r>
-              <a:rPr lang="de-AT" noProof="0" dirty="0"/>
-              <a:t>SMB Shares</a:t>
-            </a:r>
-          </a:p>
-          <a:p>
-            <a:r>
-              <a:rPr lang="de-AT" noProof="0" dirty="0"/>
-              <a:t>Einfache Bedienung / Wartung</a:t>
-            </a:r>
-          </a:p>
-          <a:p>
-            <a:r>
-              <a:rPr lang="de-AT" noProof="0" dirty="0"/>
-              <a:t>Raid 1</a:t>
-            </a:r>
-          </a:p>
-          <a:p>
-            <a:r>
-              <a:rPr lang="de-AT" noProof="0" dirty="0"/>
-              <a:t>Zusätzlicher Service (</a:t>
-            </a:r>
-            <a:r>
-              <a:rPr lang="de-AT" noProof="0" dirty="0" err="1"/>
-              <a:t>Jellyfin</a:t>
-            </a:r>
-            <a:r>
-              <a:rPr lang="de-AT" noProof="0" dirty="0"/>
-              <a:t>, </a:t>
-            </a:r>
-            <a:r>
-              <a:rPr lang="de-AT" noProof="0" dirty="0" err="1"/>
-              <a:t>qbittorrent</a:t>
-            </a:r>
-            <a:r>
-              <a:rPr lang="de-AT" noProof="0" dirty="0"/>
-              <a:t>)</a:t>
-            </a:r>
-          </a:p>
-          <a:p>
-            <a:endParaRPr lang="de-AT" noProof="0" dirty="0"/>
-          </a:p>
-        </p:txBody>
-      </p:sp>
-      <p:sp>
-        <p:nvSpPr>
-          <p:cNvPr id="6" name="Slide Number Placeholder 5">
-            <a:extLst>
-              <a:ext uri="{FF2B5EF4-FFF2-40B4-BE49-F238E27FC236}">
-                <a16:creationId xmlns:a16="http://schemas.microsoft.com/office/drawing/2014/main" id="{9000D2D5-FD9B-60A1-E0C0-390C58C1CC00}"/>
+              <a:rPr lang="en-US" dirty="0"/>
+              <a:t>Network attached storage</a:t>
+            </a:r>
+          </a:p>
+          <a:p>
+            <a:r>
+              <a:rPr lang="en-US" dirty="0" err="1"/>
+              <a:t>Datenserver</a:t>
+            </a:r>
+            <a:endParaRPr lang="en-US" dirty="0"/>
+          </a:p>
+          <a:p>
+            <a:r>
+              <a:rPr lang="en-US" dirty="0"/>
+              <a:t>Backups</a:t>
+            </a:r>
+          </a:p>
+          <a:p>
+            <a:r>
+              <a:rPr lang="en-US"/>
+              <a:t>Raid-Systeme</a:t>
+            </a:r>
+          </a:p>
+          <a:p>
+            <a:pPr marL="0" indent="0">
+              <a:buNone/>
+            </a:pPr>
+            <a:endParaRPr lang="en-US" dirty="0"/>
+          </a:p>
+          <a:p>
+            <a:endParaRPr lang="en-US" dirty="0"/>
+          </a:p>
+        </p:txBody>
+      </p:sp>
+      <p:sp>
+        <p:nvSpPr>
+          <p:cNvPr id="4" name="Slide Number Placeholder 3">
+            <a:extLst>
+              <a:ext uri="{FF2B5EF4-FFF2-40B4-BE49-F238E27FC236}">
+                <a16:creationId xmlns:a16="http://schemas.microsoft.com/office/drawing/2014/main" id="{4470938F-136B-B9F6-54AB-E2D6EA017CEB}"/>
               </a:ext>
             </a:extLst>
           </p:cNvPr>
@@ -11628,10 +11972,40 @@
           </a:p>
         </p:txBody>
       </p:sp>
+      <p:pic>
+        <p:nvPicPr>
+          <p:cNvPr id="7" name="Picture 6">
+            <a:extLst>
+              <a:ext uri="{FF2B5EF4-FFF2-40B4-BE49-F238E27FC236}">
+                <a16:creationId xmlns:a16="http://schemas.microsoft.com/office/drawing/2014/main" id="{B9F91517-9BBE-15B6-1A7D-20ABB2EE121D}"/>
+              </a:ext>
+            </a:extLst>
+          </p:cNvPr>
+          <p:cNvPicPr>
+            <a:picLocks noChangeAspect="1"/>
+          </p:cNvPicPr>
+          <p:nvPr/>
+        </p:nvPicPr>
+        <p:blipFill>
+          <a:blip r:embed="rId2"/>
+          <a:stretch>
+            <a:fillRect/>
+          </a:stretch>
+        </p:blipFill>
+        <p:spPr>
+          <a:xfrm>
+            <a:off x="7452227" y="1743964"/>
+            <a:ext cx="4241800" cy="2540000"/>
+          </a:xfrm>
+          <a:prstGeom prst="rect">
+            <a:avLst/>
+          </a:prstGeom>
+        </p:spPr>
+      </p:pic>
     </p:spTree>
     <p:extLst>
       <p:ext uri="{BB962C8B-B14F-4D97-AF65-F5344CB8AC3E}">
-        <p14:creationId xmlns:p14="http://schemas.microsoft.com/office/powerpoint/2010/main" val="3293452096"/>
+        <p14:creationId xmlns:p14="http://schemas.microsoft.com/office/powerpoint/2010/main" val="1373828103"/>
       </p:ext>
     </p:extLst>
   </p:cSld>
@@ -11658,6 +12032,164 @@
           <a:chExt cx="0" cy="0"/>
         </a:xfrm>
       </p:grpSpPr>
+      <p:sp>
+        <p:nvSpPr>
+          <p:cNvPr id="4" name="Title 3">
+            <a:extLst>
+              <a:ext uri="{FF2B5EF4-FFF2-40B4-BE49-F238E27FC236}">
+                <a16:creationId xmlns:a16="http://schemas.microsoft.com/office/drawing/2014/main" id="{F02B2A6D-D443-64DF-A247-E4AA331BF69F}"/>
+              </a:ext>
+            </a:extLst>
+          </p:cNvPr>
+          <p:cNvSpPr>
+            <a:spLocks noGrp="1"/>
+          </p:cNvSpPr>
+          <p:nvPr>
+            <p:ph type="title"/>
+          </p:nvPr>
+        </p:nvSpPr>
+        <p:spPr/>
+        <p:txBody>
+          <a:bodyPr/>
+          <a:lstStyle/>
+          <a:p>
+            <a:r>
+              <a:rPr lang="de-AT" noProof="0" dirty="0"/>
+              <a:t>Anforderungen / Ziele</a:t>
+            </a:r>
+          </a:p>
+        </p:txBody>
+      </p:sp>
+      <p:sp>
+        <p:nvSpPr>
+          <p:cNvPr id="5" name="Content Placeholder 4">
+            <a:extLst>
+              <a:ext uri="{FF2B5EF4-FFF2-40B4-BE49-F238E27FC236}">
+                <a16:creationId xmlns:a16="http://schemas.microsoft.com/office/drawing/2014/main" id="{A7222352-63ED-3606-B9DE-7D12CBFE32A4}"/>
+              </a:ext>
+            </a:extLst>
+          </p:cNvPr>
+          <p:cNvSpPr>
+            <a:spLocks noGrp="1"/>
+          </p:cNvSpPr>
+          <p:nvPr>
+            <p:ph idx="1"/>
+          </p:nvPr>
+        </p:nvSpPr>
+        <p:spPr/>
+        <p:txBody>
+          <a:bodyPr/>
+          <a:lstStyle/>
+          <a:p>
+            <a:r>
+              <a:rPr lang="de-AT" noProof="0" dirty="0"/>
+              <a:t>Mehrere User mit eigenen Privaten Ordnern</a:t>
+            </a:r>
+          </a:p>
+          <a:p>
+            <a:r>
+              <a:rPr lang="de-AT" noProof="0" dirty="0"/>
+              <a:t>SMB Shares</a:t>
+            </a:r>
+          </a:p>
+          <a:p>
+            <a:r>
+              <a:rPr lang="de-AT" noProof="0" dirty="0"/>
+              <a:t>Einfache Bedienung / Wartung</a:t>
+            </a:r>
+          </a:p>
+          <a:p>
+            <a:r>
+              <a:rPr lang="de-AT" noProof="0" dirty="0"/>
+              <a:t>Raid 1</a:t>
+            </a:r>
+          </a:p>
+          <a:p>
+            <a:r>
+              <a:rPr lang="de-AT" noProof="0" dirty="0"/>
+              <a:t>Zusätzlicher Service (</a:t>
+            </a:r>
+            <a:r>
+              <a:rPr lang="de-AT" noProof="0" dirty="0" err="1"/>
+              <a:t>Jellyfin</a:t>
+            </a:r>
+            <a:r>
+              <a:rPr lang="de-AT" noProof="0" dirty="0"/>
+              <a:t>, </a:t>
+            </a:r>
+            <a:r>
+              <a:rPr lang="de-AT" noProof="0" dirty="0" err="1"/>
+              <a:t>qbittorrent</a:t>
+            </a:r>
+            <a:r>
+              <a:rPr lang="de-AT" noProof="0" dirty="0"/>
+              <a:t>)</a:t>
+            </a:r>
+          </a:p>
+          <a:p>
+            <a:endParaRPr lang="de-AT" noProof="0" dirty="0"/>
+          </a:p>
+        </p:txBody>
+      </p:sp>
+      <p:sp>
+        <p:nvSpPr>
+          <p:cNvPr id="6" name="Slide Number Placeholder 5">
+            <a:extLst>
+              <a:ext uri="{FF2B5EF4-FFF2-40B4-BE49-F238E27FC236}">
+                <a16:creationId xmlns:a16="http://schemas.microsoft.com/office/drawing/2014/main" id="{9000D2D5-FD9B-60A1-E0C0-390C58C1CC00}"/>
+              </a:ext>
+            </a:extLst>
+          </p:cNvPr>
+          <p:cNvSpPr>
+            <a:spLocks noGrp="1"/>
+          </p:cNvSpPr>
+          <p:nvPr>
+            <p:ph type="sldNum" sz="quarter" idx="12"/>
+          </p:nvPr>
+        </p:nvSpPr>
+        <p:spPr/>
+        <p:txBody>
+          <a:bodyPr/>
+          <a:lstStyle/>
+          <a:p>
+            <a:fld id="{C0D0E01E-7608-4E47-B545-5FF4C235404B}" type="slidenum">
+              <a:rPr lang="en-US" smtClean="0"/>
+              <a:t>4</a:t>
+            </a:fld>
+            <a:endParaRPr lang="en-US"/>
+          </a:p>
+        </p:txBody>
+      </p:sp>
+    </p:spTree>
+    <p:extLst>
+      <p:ext uri="{BB962C8B-B14F-4D97-AF65-F5344CB8AC3E}">
+        <p14:creationId xmlns:p14="http://schemas.microsoft.com/office/powerpoint/2010/main" val="3293452096"/>
+      </p:ext>
+    </p:extLst>
+  </p:cSld>
+  <p:clrMapOvr>
+    <a:masterClrMapping/>
+  </p:clrMapOvr>
+</p:sld>
+</file>
+
+<file path=ppt/slides/slide5.xml><?xml version="1.0" encoding="utf-8"?>
+<p:sld xmlns:a="http://schemas.openxmlformats.org/drawingml/2006/main" xmlns:r="http://schemas.openxmlformats.org/officeDocument/2006/relationships" xmlns:p="http://schemas.openxmlformats.org/presentationml/2006/main">
+  <p:cSld>
+    <p:spTree>
+      <p:nvGrpSpPr>
+        <p:cNvPr id="1" name=""/>
+        <p:cNvGrpSpPr/>
+        <p:nvPr/>
+      </p:nvGrpSpPr>
+      <p:grpSpPr>
+        <a:xfrm>
+          <a:off x="0" y="0"/>
+          <a:ext cx="0" cy="0"/>
+          <a:chOff x="0" y="0"/>
+          <a:chExt cx="0" cy="0"/>
+        </a:xfrm>
+      </p:grpSpPr>
       <p:pic>
         <p:nvPicPr>
           <p:cNvPr id="7" name="Picture 6" descr="Refurbished DS223j | Synology Inc.">
@@ -11674,6 +12206,7 @@
         </p:nvPicPr>
         <p:blipFill>
           <a:blip r:embed="rId2"/>
+          <a:srcRect b="6147"/>
           <a:stretch>
             <a:fillRect/>
           </a:stretch>
@@ -11681,7 +12214,7 @@
         <p:spPr>
           <a:xfrm>
             <a:off x="6978556" y="4828061"/>
-            <a:ext cx="4114283" cy="2153142"/>
+            <a:ext cx="4114283" cy="2020795"/>
           </a:xfrm>
           <a:prstGeom prst="rect">
             <a:avLst/>
@@ -12860,7 +13393,7 @@
           <a:p>
             <a:fld id="{C0D0E01E-7608-4E47-B545-5FF4C235404B}" type="slidenum">
               <a:rPr lang="en-US" smtClean="0"/>
-              <a:t>4</a:t>
+              <a:t>5</a:t>
             </a:fld>
             <a:endParaRPr lang="en-US"/>
           </a:p>
@@ -12879,7 +13412,7 @@
 </p:sld>
 </file>
 
-<file path=ppt/slides/slide5.xml><?xml version="1.0" encoding="utf-8"?>
+<file path=ppt/slides/slide6.xml><?xml version="1.0" encoding="utf-8"?>
 <p:sld xmlns:a="http://schemas.openxmlformats.org/drawingml/2006/main" xmlns:r="http://schemas.openxmlformats.org/officeDocument/2006/relationships" xmlns:p="http://schemas.openxmlformats.org/presentationml/2006/main">
   <p:cSld>
     <p:spTree>
@@ -13205,7 +13738,7 @@
           <a:p>
             <a:fld id="{C0D0E01E-7608-4E47-B545-5FF4C235404B}" type="slidenum">
               <a:rPr lang="en-US" smtClean="0"/>
-              <a:t>5</a:t>
+              <a:t>6</a:t>
             </a:fld>
             <a:endParaRPr lang="en-US"/>
           </a:p>
@@ -13215,139 +13748,6 @@
     <p:extLst>
       <p:ext uri="{BB962C8B-B14F-4D97-AF65-F5344CB8AC3E}">
         <p14:creationId xmlns:p14="http://schemas.microsoft.com/office/powerpoint/2010/main" val="1978826812"/>
-      </p:ext>
-    </p:extLst>
-  </p:cSld>
-  <p:clrMapOvr>
-    <a:masterClrMapping/>
-  </p:clrMapOvr>
-</p:sld>
-</file>
-
-<file path=ppt/slides/slide6.xml><?xml version="1.0" encoding="utf-8"?>
-<p:sld xmlns:a="http://schemas.openxmlformats.org/drawingml/2006/main" xmlns:r="http://schemas.openxmlformats.org/officeDocument/2006/relationships" xmlns:p="http://schemas.openxmlformats.org/presentationml/2006/main">
-  <p:cSld>
-    <p:spTree>
-      <p:nvGrpSpPr>
-        <p:cNvPr id="1" name=""/>
-        <p:cNvGrpSpPr/>
-        <p:nvPr/>
-      </p:nvGrpSpPr>
-      <p:grpSpPr>
-        <a:xfrm>
-          <a:off x="0" y="0"/>
-          <a:ext cx="0" cy="0"/>
-          <a:chOff x="0" y="0"/>
-          <a:chExt cx="0" cy="0"/>
-        </a:xfrm>
-      </p:grpSpPr>
-      <p:sp>
-        <p:nvSpPr>
-          <p:cNvPr id="2" name="Title 1">
-            <a:extLst>
-              <a:ext uri="{FF2B5EF4-FFF2-40B4-BE49-F238E27FC236}">
-                <a16:creationId xmlns:a16="http://schemas.microsoft.com/office/drawing/2014/main" id="{C160FD5C-2CC9-E40F-1DBA-79674ED7CC1A}"/>
-              </a:ext>
-            </a:extLst>
-          </p:cNvPr>
-          <p:cNvSpPr>
-            <a:spLocks noGrp="1"/>
-          </p:cNvSpPr>
-          <p:nvPr>
-            <p:ph type="title"/>
-          </p:nvPr>
-        </p:nvSpPr>
-        <p:spPr/>
-        <p:txBody>
-          <a:bodyPr/>
-          <a:lstStyle/>
-          <a:p>
-            <a:r>
-              <a:rPr lang="de-AT" noProof="0" dirty="0"/>
-              <a:t>Unsere Hardware</a:t>
-            </a:r>
-          </a:p>
-        </p:txBody>
-      </p:sp>
-      <p:sp>
-        <p:nvSpPr>
-          <p:cNvPr id="3" name="Content Placeholder 2">
-            <a:extLst>
-              <a:ext uri="{FF2B5EF4-FFF2-40B4-BE49-F238E27FC236}">
-                <a16:creationId xmlns:a16="http://schemas.microsoft.com/office/drawing/2014/main" id="{2ABD7001-984F-43CE-08E6-58D467F90119}"/>
-              </a:ext>
-            </a:extLst>
-          </p:cNvPr>
-          <p:cNvSpPr>
-            <a:spLocks noGrp="1"/>
-          </p:cNvSpPr>
-          <p:nvPr>
-            <p:ph idx="1"/>
-          </p:nvPr>
-        </p:nvSpPr>
-        <p:spPr/>
-        <p:txBody>
-          <a:bodyPr/>
-          <a:lstStyle/>
-          <a:p>
-            <a:r>
-              <a:rPr lang="de-AT" noProof="0" dirty="0"/>
-              <a:t>Intel Core i5-3570 (4 Kerne)</a:t>
-            </a:r>
-          </a:p>
-          <a:p>
-            <a:r>
-              <a:rPr lang="de-AT" noProof="0" dirty="0"/>
-              <a:t>9,6 GB RAM</a:t>
-            </a:r>
-          </a:p>
-          <a:p>
-            <a:r>
-              <a:rPr lang="de-AT" noProof="0" dirty="0"/>
-              <a:t>2x 320 GB HDD</a:t>
-            </a:r>
-          </a:p>
-          <a:p>
-            <a:r>
-              <a:rPr lang="de-AT" noProof="0" dirty="0"/>
-              <a:t>1x 250 GB HDD</a:t>
-            </a:r>
-          </a:p>
-        </p:txBody>
-      </p:sp>
-      <p:sp>
-        <p:nvSpPr>
-          <p:cNvPr id="4" name="Slide Number Placeholder 3">
-            <a:extLst>
-              <a:ext uri="{FF2B5EF4-FFF2-40B4-BE49-F238E27FC236}">
-                <a16:creationId xmlns:a16="http://schemas.microsoft.com/office/drawing/2014/main" id="{EB29CD1E-7F34-A8CC-99A5-60FB7B167DC7}"/>
-              </a:ext>
-            </a:extLst>
-          </p:cNvPr>
-          <p:cNvSpPr>
-            <a:spLocks noGrp="1"/>
-          </p:cNvSpPr>
-          <p:nvPr>
-            <p:ph type="sldNum" sz="quarter" idx="12"/>
-          </p:nvPr>
-        </p:nvSpPr>
-        <p:spPr/>
-        <p:txBody>
-          <a:bodyPr/>
-          <a:lstStyle/>
-          <a:p>
-            <a:fld id="{C0D0E01E-7608-4E47-B545-5FF4C235404B}" type="slidenum">
-              <a:rPr lang="en-US" smtClean="0"/>
-              <a:t>6</a:t>
-            </a:fld>
-            <a:endParaRPr lang="en-US"/>
-          </a:p>
-        </p:txBody>
-      </p:sp>
-    </p:spTree>
-    <p:extLst>
-      <p:ext uri="{BB962C8B-B14F-4D97-AF65-F5344CB8AC3E}">
-        <p14:creationId xmlns:p14="http://schemas.microsoft.com/office/powerpoint/2010/main" val="2430323253"/>
       </p:ext>
     </p:extLst>
   </p:cSld>
@@ -13379,7 +13779,7 @@
           <p:cNvPr id="2" name="Title 1">
             <a:extLst>
               <a:ext uri="{FF2B5EF4-FFF2-40B4-BE49-F238E27FC236}">
-                <a16:creationId xmlns:a16="http://schemas.microsoft.com/office/drawing/2014/main" id="{C544EE85-F580-D829-4B13-357EF609A031}"/>
+                <a16:creationId xmlns:a16="http://schemas.microsoft.com/office/drawing/2014/main" id="{C160FD5C-2CC9-E40F-1DBA-79674ED7CC1A}"/>
               </a:ext>
             </a:extLst>
           </p:cNvPr>
@@ -13388,41 +13788,6 @@
           </p:cNvSpPr>
           <p:nvPr>
             <p:ph type="title"/>
-          </p:nvPr>
-        </p:nvSpPr>
-        <p:spPr/>
-        <p:txBody>
-          <a:bodyPr>
-            <a:normAutofit/>
-          </a:bodyPr>
-          <a:lstStyle/>
-          <a:p>
-            <a:r>
-              <a:rPr lang="de-AT" noProof="0" dirty="0"/>
-              <a:t>Aufbau </a:t>
-            </a:r>
-            <a:r>
-              <a:rPr lang="de-AT" noProof="0" dirty="0" err="1"/>
-              <a:t>Proxmox</a:t>
-            </a:r>
-            <a:endParaRPr lang="de-AT" noProof="0" dirty="0"/>
-          </a:p>
-        </p:txBody>
-      </p:sp>
-      <p:sp>
-        <p:nvSpPr>
-          <p:cNvPr id="14" name="Content Placeholder 2">
-            <a:extLst>
-              <a:ext uri="{FF2B5EF4-FFF2-40B4-BE49-F238E27FC236}">
-                <a16:creationId xmlns:a16="http://schemas.microsoft.com/office/drawing/2014/main" id="{99C3FBCA-B9AA-39A1-93A4-B4069BD502C4}"/>
-              </a:ext>
-            </a:extLst>
-          </p:cNvPr>
-          <p:cNvSpPr>
-            <a:spLocks noGrp="1"/>
-          </p:cNvSpPr>
-          <p:nvPr>
-            <p:ph idx="1"/>
           </p:nvPr>
         </p:nvSpPr>
         <p:spPr/>
@@ -13432,62 +13797,71 @@
           <a:p>
             <a:r>
               <a:rPr lang="de-AT" noProof="0" dirty="0"/>
-              <a:t>CPU, RAM und 250GB HDD werden aufgeteilt</a:t>
-            </a:r>
-          </a:p>
+              <a:t>Unsere Hardware</a:t>
+            </a:r>
+          </a:p>
+        </p:txBody>
+      </p:sp>
+      <p:sp>
+        <p:nvSpPr>
+          <p:cNvPr id="3" name="Content Placeholder 2">
+            <a:extLst>
+              <a:ext uri="{FF2B5EF4-FFF2-40B4-BE49-F238E27FC236}">
+                <a16:creationId xmlns:a16="http://schemas.microsoft.com/office/drawing/2014/main" id="{2ABD7001-984F-43CE-08E6-58D467F90119}"/>
+              </a:ext>
+            </a:extLst>
+          </p:cNvPr>
+          <p:cNvSpPr>
+            <a:spLocks noGrp="1"/>
+          </p:cNvSpPr>
+          <p:nvPr>
+            <p:ph idx="1"/>
+          </p:nvPr>
+        </p:nvSpPr>
+        <p:spPr/>
+        <p:txBody>
+          <a:bodyPr/>
+          <a:lstStyle/>
           <a:p>
             <a:r>
               <a:rPr lang="de-AT" noProof="0" dirty="0"/>
-              <a:t>2x 320GB HDD als Speicher mit konfigurierbaren Zugriff</a:t>
-            </a:r>
-          </a:p>
-        </p:txBody>
-      </p:sp>
-      <p:pic>
-        <p:nvPicPr>
-          <p:cNvPr id="9" name="Picture 8">
-            <a:extLst>
-              <a:ext uri="{FF2B5EF4-FFF2-40B4-BE49-F238E27FC236}">
-                <a16:creationId xmlns:a16="http://schemas.microsoft.com/office/drawing/2014/main" id="{9A03CA70-F74F-8140-D487-51FAE4170F7A}"/>
-              </a:ext>
-            </a:extLst>
-          </p:cNvPr>
-          <p:cNvPicPr>
-            <a:picLocks noChangeAspect="1"/>
-          </p:cNvPicPr>
-          <p:nvPr/>
-        </p:nvPicPr>
-        <p:blipFill>
-          <a:blip r:embed="rId2"/>
-          <a:stretch>
-            <a:fillRect/>
-          </a:stretch>
-        </p:blipFill>
-        <p:spPr>
-          <a:xfrm>
-            <a:off x="5862520" y="1834524"/>
-            <a:ext cx="6299030" cy="5023476"/>
-          </a:xfrm>
-          <a:prstGeom prst="rect">
-            <a:avLst/>
-          </a:prstGeom>
-          <a:noFill/>
-        </p:spPr>
-      </p:pic>
-      <p:sp>
-        <p:nvSpPr>
-          <p:cNvPr id="10" name="Slide Number Placeholder 9">
-            <a:extLst>
-              <a:ext uri="{FF2B5EF4-FFF2-40B4-BE49-F238E27FC236}">
-                <a16:creationId xmlns:a16="http://schemas.microsoft.com/office/drawing/2014/main" id="{A575CBD0-577C-E52B-9189-523FF9053A62}"/>
-              </a:ext>
-            </a:extLst>
-          </p:cNvPr>
-          <p:cNvSpPr>
-            <a:spLocks noGrp="1"/>
-          </p:cNvSpPr>
-          <p:nvPr>
-            <p:ph type="sldNum" sz="quarter" idx="16"/>
+              <a:t>Intel Core i5-3570 (4 Kerne)</a:t>
+            </a:r>
+          </a:p>
+          <a:p>
+            <a:r>
+              <a:rPr lang="de-AT" noProof="0" dirty="0"/>
+              <a:t>9,6 GB RAM</a:t>
+            </a:r>
+          </a:p>
+          <a:p>
+            <a:r>
+              <a:rPr lang="de-AT" noProof="0" dirty="0"/>
+              <a:t>2x 320 GB HDD</a:t>
+            </a:r>
+          </a:p>
+          <a:p>
+            <a:r>
+              <a:rPr lang="de-AT" noProof="0" dirty="0"/>
+              <a:t>1x 250 GB HDD</a:t>
+            </a:r>
+          </a:p>
+        </p:txBody>
+      </p:sp>
+      <p:sp>
+        <p:nvSpPr>
+          <p:cNvPr id="4" name="Slide Number Placeholder 3">
+            <a:extLst>
+              <a:ext uri="{FF2B5EF4-FFF2-40B4-BE49-F238E27FC236}">
+                <a16:creationId xmlns:a16="http://schemas.microsoft.com/office/drawing/2014/main" id="{EB29CD1E-7F34-A8CC-99A5-60FB7B167DC7}"/>
+              </a:ext>
+            </a:extLst>
+          </p:cNvPr>
+          <p:cNvSpPr>
+            <a:spLocks noGrp="1"/>
+          </p:cNvSpPr>
+          <p:nvPr>
+            <p:ph type="sldNum" sz="quarter" idx="12"/>
           </p:nvPr>
         </p:nvSpPr>
         <p:spPr/>
@@ -13503,40 +13877,10 @@
           </a:p>
         </p:txBody>
       </p:sp>
-      <p:pic>
-        <p:nvPicPr>
-          <p:cNvPr id="3" name="Picture 2" descr="Proxmox Icon &amp; Logo (selfh.st) | Dashboard Icons &amp; Logos">
-            <a:extLst>
-              <a:ext uri="{FF2B5EF4-FFF2-40B4-BE49-F238E27FC236}">
-                <a16:creationId xmlns:a16="http://schemas.microsoft.com/office/drawing/2014/main" id="{AC65BA14-6BDB-5856-5332-C7BDE53B9C4F}"/>
-              </a:ext>
-            </a:extLst>
-          </p:cNvPr>
-          <p:cNvPicPr>
-            <a:picLocks noChangeAspect="1"/>
-          </p:cNvPicPr>
-          <p:nvPr/>
-        </p:nvPicPr>
-        <p:blipFill>
-          <a:blip r:embed="rId3"/>
-          <a:stretch>
-            <a:fillRect/>
-          </a:stretch>
-        </p:blipFill>
-        <p:spPr>
-          <a:xfrm>
-            <a:off x="5862520" y="560239"/>
-            <a:ext cx="1149689" cy="1149689"/>
-          </a:xfrm>
-          <a:prstGeom prst="rect">
-            <a:avLst/>
-          </a:prstGeom>
-        </p:spPr>
-      </p:pic>
     </p:spTree>
     <p:extLst>
       <p:ext uri="{BB962C8B-B14F-4D97-AF65-F5344CB8AC3E}">
-        <p14:creationId xmlns:p14="http://schemas.microsoft.com/office/powerpoint/2010/main" val="3541148481"/>
+        <p14:creationId xmlns:p14="http://schemas.microsoft.com/office/powerpoint/2010/main" val="2430323253"/>
       </p:ext>
     </p:extLst>
   </p:cSld>
@@ -13565,10 +13909,10 @@
       </p:grpSpPr>
       <p:sp>
         <p:nvSpPr>
-          <p:cNvPr id="5" name="Title 4">
-            <a:extLst>
-              <a:ext uri="{FF2B5EF4-FFF2-40B4-BE49-F238E27FC236}">
-                <a16:creationId xmlns:a16="http://schemas.microsoft.com/office/drawing/2014/main" id="{AB223F16-287D-411A-C8CD-B223D8AA4747}"/>
+          <p:cNvPr id="4" name="Title 3">
+            <a:extLst>
+              <a:ext uri="{FF2B5EF4-FFF2-40B4-BE49-F238E27FC236}">
+                <a16:creationId xmlns:a16="http://schemas.microsoft.com/office/drawing/2014/main" id="{F02B2A6D-D443-64DF-A247-E4AA331BF69F}"/>
               </a:ext>
             </a:extLst>
           </p:cNvPr>
@@ -13585,34 +13929,18 @@
           <a:lstStyle/>
           <a:p>
             <a:r>
-              <a:rPr lang="de-AT" noProof="0" dirty="0"/>
-              <a:t>Warum </a:t>
-            </a:r>
-            <a:r>
-              <a:rPr lang="de-AT" noProof="0" dirty="0" err="1"/>
-              <a:t>Proxmox</a:t>
-            </a:r>
-            <a:r>
-              <a:rPr lang="de-AT" noProof="0" dirty="0"/>
-              <a:t> mit </a:t>
-            </a:r>
-            <a:r>
-              <a:rPr lang="de-AT" noProof="0" dirty="0" err="1"/>
-              <a:t>Truenas</a:t>
-            </a:r>
-            <a:r>
-              <a:rPr lang="de-AT" noProof="0" dirty="0"/>
-              <a:t>?</a:t>
-            </a:r>
-          </a:p>
-        </p:txBody>
-      </p:sp>
-      <p:sp>
-        <p:nvSpPr>
-          <p:cNvPr id="6" name="Content Placeholder 5">
-            <a:extLst>
-              <a:ext uri="{FF2B5EF4-FFF2-40B4-BE49-F238E27FC236}">
-                <a16:creationId xmlns:a16="http://schemas.microsoft.com/office/drawing/2014/main" id="{4055BCF1-EAD7-301E-60E9-215796AAF546}"/>
+              <a:rPr lang="de-AT" dirty="0"/>
+              <a:t>Inhaltsangabe </a:t>
+            </a:r>
+          </a:p>
+        </p:txBody>
+      </p:sp>
+      <p:sp>
+        <p:nvSpPr>
+          <p:cNvPr id="5" name="Content Placeholder 4">
+            <a:extLst>
+              <a:ext uri="{FF2B5EF4-FFF2-40B4-BE49-F238E27FC236}">
+                <a16:creationId xmlns:a16="http://schemas.microsoft.com/office/drawing/2014/main" id="{A7222352-63ED-3606-B9DE-7D12CBFE32A4}"/>
               </a:ext>
             </a:extLst>
           </p:cNvPr>
@@ -13629,44 +13957,86 @@
           <a:lstStyle/>
           <a:p>
             <a:r>
-              <a:rPr lang="de-AT" noProof="0" dirty="0" err="1"/>
+              <a:rPr lang="de-AT" dirty="0"/>
+              <a:t>Aufbau mit </a:t>
+            </a:r>
+            <a:r>
+              <a:rPr lang="de-AT" dirty="0" err="1"/>
               <a:t>Proxmox</a:t>
             </a:r>
-            <a:r>
-              <a:rPr lang="de-AT" noProof="0" dirty="0"/>
-              <a:t> wegen Kenntnissen vom eigenen Serverbau</a:t>
-            </a:r>
-          </a:p>
-          <a:p>
-            <a:r>
-              <a:rPr lang="de-AT" noProof="0" dirty="0"/>
-              <a:t>Zusätzliche Services mit Helper Scripts einfach installierbar</a:t>
-            </a:r>
-          </a:p>
-          <a:p>
-            <a:r>
-              <a:rPr lang="de-AT" noProof="0" dirty="0"/>
-              <a:t>Services sind Leicht trennbar</a:t>
-            </a:r>
-          </a:p>
-          <a:p>
-            <a:r>
-              <a:rPr lang="de-AT" noProof="0" dirty="0" err="1"/>
+            <a:endParaRPr lang="de-AT" dirty="0"/>
+          </a:p>
+          <a:p>
+            <a:r>
+              <a:rPr lang="de-AT" dirty="0"/>
+              <a:t>Warum </a:t>
+            </a:r>
+            <a:r>
+              <a:rPr lang="de-AT" dirty="0" err="1"/>
+              <a:t>Proxmox</a:t>
+            </a:r>
+            <a:r>
+              <a:rPr lang="de-AT" dirty="0"/>
+              <a:t> mit </a:t>
+            </a:r>
+            <a:r>
+              <a:rPr lang="de-AT" dirty="0" err="1"/>
               <a:t>TrueNAS</a:t>
             </a:r>
             <a:r>
-              <a:rPr lang="de-AT" noProof="0" dirty="0"/>
-              <a:t> hat eine schöne Oberfläche und ist einfach konfigurierbar</a:t>
-            </a:r>
-          </a:p>
-        </p:txBody>
-      </p:sp>
-      <p:sp>
-        <p:nvSpPr>
-          <p:cNvPr id="7" name="Slide Number Placeholder 6">
-            <a:extLst>
-              <a:ext uri="{FF2B5EF4-FFF2-40B4-BE49-F238E27FC236}">
-                <a16:creationId xmlns:a16="http://schemas.microsoft.com/office/drawing/2014/main" id="{AD11AFFF-5229-F451-61F1-887D21EF3322}"/>
+              <a:rPr lang="de-AT" dirty="0"/>
+              <a:t>?</a:t>
+            </a:r>
+          </a:p>
+          <a:p>
+            <a:r>
+              <a:rPr lang="de-AT" dirty="0"/>
+              <a:t>Festplatten-Setup und RAID 1</a:t>
+            </a:r>
+          </a:p>
+          <a:p>
+            <a:r>
+              <a:rPr lang="de-AT" dirty="0" err="1"/>
+              <a:t>TrueNAS</a:t>
+            </a:r>
+            <a:r>
+              <a:rPr lang="de-AT" dirty="0"/>
+              <a:t>: Datasets und Freigaben</a:t>
+            </a:r>
+          </a:p>
+          <a:p>
+            <a:r>
+              <a:rPr lang="de-AT" dirty="0"/>
+              <a:t>Services: </a:t>
+            </a:r>
+            <a:r>
+              <a:rPr lang="de-AT" dirty="0" err="1"/>
+              <a:t>Jellyfin</a:t>
+            </a:r>
+            <a:r>
+              <a:rPr lang="de-AT" dirty="0"/>
+              <a:t> und </a:t>
+            </a:r>
+            <a:r>
+              <a:rPr lang="de-AT" dirty="0" err="1"/>
+              <a:t>qBittorrent</a:t>
+            </a:r>
+            <a:endParaRPr lang="de-AT" dirty="0"/>
+          </a:p>
+          <a:p>
+            <a:r>
+              <a:rPr lang="de-AT" dirty="0"/>
+              <a:t>Schreib- und Lesegeschwindigkeit</a:t>
+            </a:r>
+          </a:p>
+        </p:txBody>
+      </p:sp>
+      <p:sp>
+        <p:nvSpPr>
+          <p:cNvPr id="6" name="Slide Number Placeholder 5">
+            <a:extLst>
+              <a:ext uri="{FF2B5EF4-FFF2-40B4-BE49-F238E27FC236}">
+                <a16:creationId xmlns:a16="http://schemas.microsoft.com/office/drawing/2014/main" id="{9000D2D5-FD9B-60A1-E0C0-390C58C1CC00}"/>
               </a:ext>
             </a:extLst>
           </p:cNvPr>
@@ -13677,7 +14047,12 @@
             <p:ph type="sldNum" sz="quarter" idx="12"/>
           </p:nvPr>
         </p:nvSpPr>
-        <p:spPr/>
+        <p:spPr>
+          <a:xfrm>
+            <a:off x="11574227" y="207982"/>
+            <a:ext cx="261090" cy="404666"/>
+          </a:xfrm>
+        </p:spPr>
         <p:txBody>
           <a:bodyPr/>
           <a:lstStyle/>
@@ -13686,74 +14061,14 @@
               <a:rPr lang="en-US" smtClean="0"/>
               <a:t>8</a:t>
             </a:fld>
-            <a:endParaRPr lang="en-US"/>
-          </a:p>
-        </p:txBody>
-      </p:sp>
-      <p:pic>
-        <p:nvPicPr>
-          <p:cNvPr id="2" name="Picture 1" descr="Proxmox Icon &amp; Logo (selfh.st) | Dashboard Icons &amp; Logos">
-            <a:extLst>
-              <a:ext uri="{FF2B5EF4-FFF2-40B4-BE49-F238E27FC236}">
-                <a16:creationId xmlns:a16="http://schemas.microsoft.com/office/drawing/2014/main" id="{1D2B0203-C2B3-C9E1-6EAE-BDE02BCB0375}"/>
-              </a:ext>
-            </a:extLst>
-          </p:cNvPr>
-          <p:cNvPicPr>
-            <a:picLocks noChangeAspect="1"/>
-          </p:cNvPicPr>
-          <p:nvPr/>
-        </p:nvPicPr>
-        <p:blipFill>
-          <a:blip r:embed="rId2"/>
-          <a:stretch>
-            <a:fillRect/>
-          </a:stretch>
-        </p:blipFill>
-        <p:spPr>
-          <a:xfrm>
-            <a:off x="617773" y="4451684"/>
-            <a:ext cx="1577474" cy="1577474"/>
-          </a:xfrm>
-          <a:prstGeom prst="rect">
-            <a:avLst/>
-          </a:prstGeom>
-        </p:spPr>
-      </p:pic>
-      <p:pic>
-        <p:nvPicPr>
-          <p:cNvPr id="3" name="Picture 2" descr="Truenas Icon &amp; Logo | Dashboard Icons &amp; Logos">
-            <a:extLst>
-              <a:ext uri="{FF2B5EF4-FFF2-40B4-BE49-F238E27FC236}">
-                <a16:creationId xmlns:a16="http://schemas.microsoft.com/office/drawing/2014/main" id="{0BA6FC60-B779-AE27-CD8A-DB044F0DC658}"/>
-              </a:ext>
-            </a:extLst>
-          </p:cNvPr>
-          <p:cNvPicPr>
-            <a:picLocks noChangeAspect="1"/>
-          </p:cNvPicPr>
-          <p:nvPr/>
-        </p:nvPicPr>
-        <p:blipFill>
-          <a:blip r:embed="rId3"/>
-          <a:stretch>
-            <a:fillRect/>
-          </a:stretch>
-        </p:blipFill>
-        <p:spPr>
-          <a:xfrm>
-            <a:off x="3007894" y="4451684"/>
-            <a:ext cx="2192421" cy="1732283"/>
-          </a:xfrm>
-          <a:prstGeom prst="rect">
-            <a:avLst/>
-          </a:prstGeom>
-        </p:spPr>
-      </p:pic>
+            <a:endParaRPr lang="en-US" dirty="0"/>
+          </a:p>
+        </p:txBody>
+      </p:sp>
     </p:spTree>
     <p:extLst>
       <p:ext uri="{BB962C8B-B14F-4D97-AF65-F5344CB8AC3E}">
-        <p14:creationId xmlns:p14="http://schemas.microsoft.com/office/powerpoint/2010/main" val="4224059100"/>
+        <p14:creationId xmlns:p14="http://schemas.microsoft.com/office/powerpoint/2010/main" val="3293452096"/>
       </p:ext>
     </p:extLst>
   </p:cSld>
@@ -13785,7 +14100,7 @@
           <p:cNvPr id="2" name="Title 1">
             <a:extLst>
               <a:ext uri="{FF2B5EF4-FFF2-40B4-BE49-F238E27FC236}">
-                <a16:creationId xmlns:a16="http://schemas.microsoft.com/office/drawing/2014/main" id="{E8FB61DF-3FC1-44F2-6593-9C30C42976AD}"/>
+                <a16:creationId xmlns:a16="http://schemas.microsoft.com/office/drawing/2014/main" id="{C544EE85-F580-D829-4B13-357EF609A031}"/>
               </a:ext>
             </a:extLst>
           </p:cNvPr>
@@ -13794,6 +14109,41 @@
           </p:cNvSpPr>
           <p:nvPr>
             <p:ph type="title"/>
+          </p:nvPr>
+        </p:nvSpPr>
+        <p:spPr/>
+        <p:txBody>
+          <a:bodyPr>
+            <a:normAutofit/>
+          </a:bodyPr>
+          <a:lstStyle/>
+          <a:p>
+            <a:r>
+              <a:rPr lang="de-AT" noProof="0" dirty="0"/>
+              <a:t>Aufbau </a:t>
+            </a:r>
+            <a:r>
+              <a:rPr lang="de-AT" noProof="0" dirty="0" err="1"/>
+              <a:t>Proxmox</a:t>
+            </a:r>
+            <a:endParaRPr lang="de-AT" noProof="0" dirty="0"/>
+          </a:p>
+        </p:txBody>
+      </p:sp>
+      <p:sp>
+        <p:nvSpPr>
+          <p:cNvPr id="14" name="Content Placeholder 2">
+            <a:extLst>
+              <a:ext uri="{FF2B5EF4-FFF2-40B4-BE49-F238E27FC236}">
+                <a16:creationId xmlns:a16="http://schemas.microsoft.com/office/drawing/2014/main" id="{99C3FBCA-B9AA-39A1-93A4-B4069BD502C4}"/>
+              </a:ext>
+            </a:extLst>
+          </p:cNvPr>
+          <p:cNvSpPr>
+            <a:spLocks noGrp="1"/>
+          </p:cNvSpPr>
+          <p:nvPr>
+            <p:ph idx="1"/>
           </p:nvPr>
         </p:nvSpPr>
         <p:spPr/>
@@ -13803,103 +14153,23 @@
           <a:p>
             <a:r>
               <a:rPr lang="de-AT" noProof="0" dirty="0"/>
-              <a:t>Festplatten </a:t>
-            </a:r>
-            <a:r>
-              <a:rPr lang="de-AT" noProof="0" dirty="0" err="1"/>
-              <a:t>setup</a:t>
-            </a:r>
-            <a:endParaRPr lang="de-AT" noProof="0" dirty="0"/>
-          </a:p>
-        </p:txBody>
-      </p:sp>
-      <p:sp>
-        <p:nvSpPr>
-          <p:cNvPr id="3" name="Content Placeholder 2">
-            <a:extLst>
-              <a:ext uri="{FF2B5EF4-FFF2-40B4-BE49-F238E27FC236}">
-                <a16:creationId xmlns:a16="http://schemas.microsoft.com/office/drawing/2014/main" id="{DDBC0929-008A-B2F3-DBCF-31456F2A6092}"/>
-              </a:ext>
-            </a:extLst>
-          </p:cNvPr>
-          <p:cNvSpPr>
-            <a:spLocks noGrp="1"/>
-          </p:cNvSpPr>
-          <p:nvPr>
-            <p:ph idx="1"/>
-          </p:nvPr>
-        </p:nvSpPr>
-        <p:spPr/>
-        <p:txBody>
-          <a:bodyPr/>
-          <a:lstStyle/>
+              <a:t>CPU, RAM und 250GB HDD werden aufgeteilt</a:t>
+            </a:r>
+          </a:p>
           <a:p>
             <a:r>
               <a:rPr lang="de-AT" noProof="0" dirty="0"/>
-              <a:t>Alle Festplatten zuerst </a:t>
-            </a:r>
-            <a:r>
-              <a:rPr lang="de-AT" noProof="0" dirty="0" err="1"/>
-              <a:t>gewiped</a:t>
-            </a:r>
-            <a:endParaRPr lang="de-AT" noProof="0" dirty="0"/>
-          </a:p>
-          <a:p>
-            <a:r>
-              <a:rPr lang="de-AT" noProof="0" dirty="0" err="1"/>
-              <a:t>Proxmox</a:t>
-            </a:r>
-            <a:r>
-              <a:rPr lang="de-AT" noProof="0" dirty="0"/>
-              <a:t> mit anderen Services auf einer 250GB HDD</a:t>
-            </a:r>
-          </a:p>
-          <a:p>
-            <a:r>
-              <a:rPr lang="de-AT" noProof="0" dirty="0"/>
-              <a:t>Raid 1 mit 2x 320GB HDD</a:t>
-            </a:r>
-          </a:p>
-          <a:p>
-            <a:endParaRPr lang="de-AT" noProof="0" dirty="0"/>
-          </a:p>
-        </p:txBody>
-      </p:sp>
-      <p:sp>
-        <p:nvSpPr>
-          <p:cNvPr id="4" name="Slide Number Placeholder 3">
-            <a:extLst>
-              <a:ext uri="{FF2B5EF4-FFF2-40B4-BE49-F238E27FC236}">
-                <a16:creationId xmlns:a16="http://schemas.microsoft.com/office/drawing/2014/main" id="{E04E097A-6A4C-C7FD-0B8F-7D7AD2841014}"/>
-              </a:ext>
-            </a:extLst>
-          </p:cNvPr>
-          <p:cNvSpPr>
-            <a:spLocks noGrp="1"/>
-          </p:cNvSpPr>
-          <p:nvPr>
-            <p:ph type="sldNum" sz="quarter" idx="12"/>
-          </p:nvPr>
-        </p:nvSpPr>
-        <p:spPr/>
-        <p:txBody>
-          <a:bodyPr/>
-          <a:lstStyle/>
-          <a:p>
-            <a:fld id="{C0D0E01E-7608-4E47-B545-5FF4C235404B}" type="slidenum">
-              <a:rPr lang="en-US" smtClean="0"/>
-              <a:t>9</a:t>
-            </a:fld>
-            <a:endParaRPr lang="en-US"/>
+              <a:t>2x 320GB HDD als Speicher mit konfigurierbaren Zugriff</a:t>
+            </a:r>
           </a:p>
         </p:txBody>
       </p:sp>
       <p:pic>
         <p:nvPicPr>
-          <p:cNvPr id="5" name="Picture 4" descr="Disc HDd Hard Download HD Transparent HQ PNG Download | FreePNGimg">
-            <a:extLst>
-              <a:ext uri="{FF2B5EF4-FFF2-40B4-BE49-F238E27FC236}">
-                <a16:creationId xmlns:a16="http://schemas.microsoft.com/office/drawing/2014/main" id="{DBE3D5C7-A2F4-BAB3-652D-6A16C40993C2}"/>
+          <p:cNvPr id="9" name="Picture 8">
+            <a:extLst>
+              <a:ext uri="{FF2B5EF4-FFF2-40B4-BE49-F238E27FC236}">
+                <a16:creationId xmlns:a16="http://schemas.microsoft.com/office/drawing/2014/main" id="{9A03CA70-F74F-8140-D487-51FAE4170F7A}"/>
               </a:ext>
             </a:extLst>
           </p:cNvPr>
@@ -13916,8 +14186,68 @@
         </p:blipFill>
         <p:spPr>
           <a:xfrm>
-            <a:off x="320559" y="3620792"/>
-            <a:ext cx="3164305" cy="2624560"/>
+            <a:off x="5862520" y="1834524"/>
+            <a:ext cx="6299030" cy="5023476"/>
+          </a:xfrm>
+          <a:prstGeom prst="rect">
+            <a:avLst/>
+          </a:prstGeom>
+          <a:noFill/>
+        </p:spPr>
+      </p:pic>
+      <p:sp>
+        <p:nvSpPr>
+          <p:cNvPr id="10" name="Slide Number Placeholder 9">
+            <a:extLst>
+              <a:ext uri="{FF2B5EF4-FFF2-40B4-BE49-F238E27FC236}">
+                <a16:creationId xmlns:a16="http://schemas.microsoft.com/office/drawing/2014/main" id="{A575CBD0-577C-E52B-9189-523FF9053A62}"/>
+              </a:ext>
+            </a:extLst>
+          </p:cNvPr>
+          <p:cNvSpPr>
+            <a:spLocks noGrp="1"/>
+          </p:cNvSpPr>
+          <p:nvPr>
+            <p:ph type="sldNum" sz="quarter" idx="16"/>
+          </p:nvPr>
+        </p:nvSpPr>
+        <p:spPr/>
+        <p:txBody>
+          <a:bodyPr/>
+          <a:lstStyle/>
+          <a:p>
+            <a:fld id="{C0D0E01E-7608-4E47-B545-5FF4C235404B}" type="slidenum">
+              <a:rPr lang="en-US" smtClean="0"/>
+              <a:t>9</a:t>
+            </a:fld>
+            <a:endParaRPr lang="en-US"/>
+          </a:p>
+        </p:txBody>
+      </p:sp>
+      <p:pic>
+        <p:nvPicPr>
+          <p:cNvPr id="3" name="Picture 2" descr="Proxmox Icon &amp; Logo (selfh.st) | Dashboard Icons &amp; Logos">
+            <a:extLst>
+              <a:ext uri="{FF2B5EF4-FFF2-40B4-BE49-F238E27FC236}">
+                <a16:creationId xmlns:a16="http://schemas.microsoft.com/office/drawing/2014/main" id="{AC65BA14-6BDB-5856-5332-C7BDE53B9C4F}"/>
+              </a:ext>
+            </a:extLst>
+          </p:cNvPr>
+          <p:cNvPicPr>
+            <a:picLocks noChangeAspect="1"/>
+          </p:cNvPicPr>
+          <p:nvPr/>
+        </p:nvPicPr>
+        <p:blipFill>
+          <a:blip r:embed="rId3"/>
+          <a:stretch>
+            <a:fillRect/>
+          </a:stretch>
+        </p:blipFill>
+        <p:spPr>
+          <a:xfrm>
+            <a:off x="5862520" y="560239"/>
+            <a:ext cx="1149689" cy="1149689"/>
           </a:xfrm>
           <a:prstGeom prst="rect">
             <a:avLst/>
@@ -13927,7 +14257,7 @@
     </p:spTree>
     <p:extLst>
       <p:ext uri="{BB962C8B-B14F-4D97-AF65-F5344CB8AC3E}">
-        <p14:creationId xmlns:p14="http://schemas.microsoft.com/office/powerpoint/2010/main" val="3441423203"/>
+        <p14:creationId xmlns:p14="http://schemas.microsoft.com/office/powerpoint/2010/main" val="3541148481"/>
       </p:ext>
     </p:extLst>
   </p:cSld>

</xml_diff>